<commit_message>
Updated the slide with real example
</commit_message>
<xml_diff>
--- a/Claude_Code_Agentic_Engineering_Session.pptx
+++ b/Claude_Code_Agentic_Engineering_Session.pptx
@@ -9,7 +9,7 @@
   </p:notesMasterIdLst>
   <p:sldIdLst>
     <p:sldId id="434" r:id="rId2"/>
-    <p:sldId id="527" r:id="rId3"/>
+    <p:sldId id="603" r:id="rId3"/>
     <p:sldId id="528" r:id="rId4"/>
     <p:sldId id="529" r:id="rId5"/>
     <p:sldId id="595" r:id="rId6"/>
@@ -1395,7 +1395,7 @@
           <a:p>
             <a:fld id="{FE9AFDDE-3A13-46FC-B67A-2ECE1914331B}" type="datetimeFigureOut">
               <a:rPr lang="en-US" smtClean="0"/>
-              <a:t>3/17/26</a:t>
+              <a:t>3/19/26</a:t>
             </a:fld>
             <a:endParaRPr lang="en-US"/>
           </a:p>
@@ -20980,7 +20980,13 @@
   <p:cSld>
     <p:spTree>
       <p:nvGrpSpPr>
-        <p:cNvPr id="1" name=""/>
+        <p:cNvPr id="1" name="">
+          <a:extLst>
+            <a:ext uri="{FF2B5EF4-FFF2-40B4-BE49-F238E27FC236}">
+              <a16:creationId xmlns:a16="http://schemas.microsoft.com/office/drawing/2014/main" id="{1FA11982-C974-C73B-CA11-F0322D4ED90E}"/>
+            </a:ext>
+          </a:extLst>
+        </p:cNvPr>
         <p:cNvGrpSpPr/>
         <p:nvPr/>
       </p:nvGrpSpPr>
@@ -20994,7 +21000,7 @@
       </p:grpSpPr>
       <p:sp>
         <p:nvSpPr>
-          <p:cNvPr id="100" name="T100"/>
+          <p:cNvPr id="100" name="S100"/>
           <p:cNvSpPr/>
           <p:nvPr/>
         </p:nvSpPr>
@@ -21007,15 +21013,15 @@
             <a:avLst/>
           </a:prstGeom>
           <a:noFill/>
-          <a:ln w="0">
-            <a:noFill/>
-          </a:ln>
-        </p:spPr>
-        <p:txBody>
-          <a:bodyPr wrap="square" lIns="0" tIns="0" rIns="0" bIns="0" anchor="t"/>
-          <a:lstStyle/>
-          <a:p>
-            <a:pPr marL="0" indent="0">
+          <a:ln>
+            <a:noFill/>
+          </a:ln>
+        </p:spPr>
+        <p:txBody>
+          <a:bodyPr wrap="square" lIns="36000" tIns="18000" rIns="36000" bIns="18000" anchor="ctr"/>
+          <a:lstStyle/>
+          <a:p>
+            <a:pPr algn="l">
               <a:buNone/>
             </a:pPr>
             <a:r>
@@ -21032,38 +21038,38 @@
       </p:sp>
       <p:sp>
         <p:nvSpPr>
-          <p:cNvPr id="101" name="T101"/>
-          <p:cNvSpPr/>
-          <p:nvPr/>
-        </p:nvSpPr>
-        <p:spPr>
-          <a:xfrm>
-            <a:off x="660400" y="609600"/>
-            <a:ext cx="9512300" cy="254000"/>
+          <p:cNvPr id="101" name="S101"/>
+          <p:cNvSpPr/>
+          <p:nvPr/>
+        </p:nvSpPr>
+        <p:spPr>
+          <a:xfrm>
+            <a:off x="660400" y="533400"/>
+            <a:ext cx="10414000" cy="304800"/>
           </a:xfrm>
           <a:prstGeom prst="rect">
             <a:avLst/>
           </a:prstGeom>
           <a:noFill/>
-          <a:ln w="0">
-            <a:noFill/>
-          </a:ln>
-        </p:spPr>
-        <p:txBody>
-          <a:bodyPr wrap="square" lIns="0" tIns="0" rIns="0" bIns="0" anchor="t"/>
-          <a:lstStyle/>
-          <a:p>
-            <a:pPr marL="0" indent="0">
+          <a:ln>
+            <a:noFill/>
+          </a:ln>
+        </p:spPr>
+        <p:txBody>
+          <a:bodyPr wrap="square" lIns="36000" tIns="18000" rIns="36000" bIns="18000" anchor="ctr"/>
+          <a:lstStyle/>
+          <a:p>
+            <a:pPr algn="l">
               <a:buNone/>
             </a:pPr>
             <a:r>
               <a:rPr lang="en-US" sz="1400" dirty="0">
                 <a:solidFill>
-                  <a:srgbClr val="3972C1"/>
+                  <a:srgbClr val="6B9BD2"/>
                 </a:solidFill>
                 <a:latin typeface="Aptos"/>
               </a:rPr>
-              <a:t>Pro, Max, Team, and Enterprise unlock Claude Code. Free tier provides chat only.</a:t>
+              <a:t>Tiers &amp; models on the left  |  Real-world eng. team analogy on the right  |  Same decision pattern</a:t>
             </a:r>
           </a:p>
         </p:txBody>
@@ -21076,105 +21082,103 @@
         </p:nvCxnSpPr>
         <p:spPr>
           <a:xfrm>
-            <a:off x="0" y="952500"/>
+            <a:off x="0" y="914400"/>
             <a:ext cx="12192000" cy="0"/>
           </a:xfrm>
-          <a:prstGeom prst="straightConnector1">
-            <a:avLst/>
-          </a:prstGeom>
+          <a:prstGeom prst="line">
+            <a:avLst/>
+          </a:prstGeom>
+          <a:ln w="12700">
+            <a:solidFill>
+              <a:srgbClr val="334155"/>
+            </a:solidFill>
+          </a:ln>
+        </p:spPr>
+      </p:cxnSp>
+      <p:sp>
+        <p:nvSpPr>
+          <p:cNvPr id="103" name="S103"/>
+          <p:cNvSpPr/>
+          <p:nvPr/>
+        </p:nvSpPr>
+        <p:spPr>
+          <a:xfrm>
+            <a:off x="146053" y="990600"/>
+            <a:ext cx="2540000" cy="203200"/>
+          </a:xfrm>
+          <a:prstGeom prst="rect">
+            <a:avLst/>
+          </a:prstGeom>
+          <a:noFill/>
+          <a:ln>
+            <a:noFill/>
+          </a:ln>
+        </p:spPr>
+        <p:txBody>
+          <a:bodyPr wrap="square" lIns="36000" tIns="18000" rIns="36000" bIns="18000" anchor="ctr"/>
+          <a:lstStyle/>
+          <a:p>
+            <a:pPr algn="l">
+              <a:buNone/>
+            </a:pPr>
+            <a:r>
+              <a:rPr lang="en-US" sz="1100" b="1" dirty="0">
+                <a:solidFill>
+                  <a:srgbClr val="64748B"/>
+                </a:solidFill>
+                <a:latin typeface="Aptos Display"/>
+              </a:rPr>
+              <a:t>SUBSCRIPTION TIERS</a:t>
+            </a:r>
+          </a:p>
+        </p:txBody>
+      </p:sp>
+      <p:sp>
+        <p:nvSpPr>
+          <p:cNvPr id="104" name="S104"/>
+          <p:cNvSpPr/>
+          <p:nvPr/>
+        </p:nvSpPr>
+        <p:spPr>
+          <a:xfrm>
+            <a:off x="146053" y="1229360"/>
+            <a:ext cx="5714997" cy="431800"/>
+          </a:xfrm>
+          <a:prstGeom prst="roundRect">
+            <a:avLst>
+              <a:gd name="adj" fmla="val 10000"/>
+            </a:avLst>
+          </a:prstGeom>
+          <a:solidFill>
+            <a:srgbClr val="EFF6FF"/>
+          </a:solidFill>
           <a:ln w="9525">
             <a:solidFill>
-              <a:srgbClr val="3972C1"/>
+              <a:srgbClr val="1565C0"/>
             </a:solidFill>
           </a:ln>
         </p:spPr>
-      </p:cxnSp>
-      <p:sp>
-        <p:nvSpPr>
-          <p:cNvPr id="103" name="T103"/>
-          <p:cNvSpPr/>
-          <p:nvPr/>
-        </p:nvSpPr>
-        <p:spPr>
-          <a:xfrm>
-            <a:off x="381000" y="1041400"/>
-            <a:ext cx="2540000" cy="203200"/>
-          </a:xfrm>
-          <a:prstGeom prst="rect">
-            <a:avLst/>
-          </a:prstGeom>
-          <a:noFill/>
-          <a:ln w="0">
-            <a:noFill/>
-          </a:ln>
-        </p:spPr>
-        <p:txBody>
-          <a:bodyPr wrap="square" lIns="0" tIns="0" rIns="0" bIns="0" anchor="t"/>
-          <a:lstStyle/>
-          <a:p>
-            <a:pPr>
-              <a:buNone/>
-            </a:pPr>
-            <a:r>
-              <a:rPr lang="en-US" sz="1100" b="1" dirty="0">
-                <a:solidFill>
-                  <a:srgbClr val="64748B"/>
-                </a:solidFill>
-                <a:latin typeface="Aptos Display"/>
-              </a:rPr>
-              <a:t>SUBSCRIPTION TIERS</a:t>
-            </a:r>
-          </a:p>
-        </p:txBody>
-      </p:sp>
-      <p:sp>
-        <p:nvSpPr>
-          <p:cNvPr id="104" name="S104"/>
-          <p:cNvSpPr/>
-          <p:nvPr/>
-        </p:nvSpPr>
-        <p:spPr>
-          <a:xfrm>
-            <a:off x="381000" y="1295400"/>
-            <a:ext cx="5334000" cy="508000"/>
-          </a:xfrm>
-          <a:prstGeom prst="roundRect">
-            <a:avLst>
-              <a:gd name="adj" fmla="val 4000"/>
-            </a:avLst>
-          </a:prstGeom>
-          <a:solidFill>
-            <a:srgbClr val="EBF5FF"/>
-          </a:solidFill>
-          <a:ln w="0">
-            <a:noFill/>
-          </a:ln>
-          <a:effectLst>
-            <a:outerShdw blurRad="25400" dist="12700" dir="5400000" algn="tl" rotWithShape="0">
-              <a:srgbClr val="000000">
-                <a:alpha val="10000"/>
-              </a:srgbClr>
-            </a:outerShdw>
-          </a:effectLst>
-        </p:spPr>
-        <p:txBody>
-          <a:bodyPr wrap="square" lIns="72000" tIns="54000" rIns="72000" bIns="54000" anchor="t"/>
-          <a:lstStyle/>
-          <a:p>
-            <a:endParaRPr lang="en-US"/>
-          </a:p>
-        </p:txBody>
-      </p:sp>
-      <p:sp>
-        <p:nvSpPr>
-          <p:cNvPr id="105" name="R105"/>
-          <p:cNvSpPr/>
-          <p:nvPr/>
-        </p:nvSpPr>
-        <p:spPr>
-          <a:xfrm>
-            <a:off x="381000" y="1295400"/>
-            <a:ext cx="50800" cy="508000"/>
+        <p:txBody>
+          <a:bodyPr wrap="square" lIns="36000" tIns="18000" rIns="36000" bIns="18000" anchor="ctr"/>
+          <a:lstStyle/>
+          <a:p>
+            <a:pPr algn="l">
+              <a:buNone/>
+            </a:pPr>
+            <a:endParaRPr/>
+          </a:p>
+        </p:txBody>
+      </p:sp>
+      <p:sp>
+        <p:nvSpPr>
+          <p:cNvPr id="105" name="S105"/>
+          <p:cNvSpPr/>
+          <p:nvPr/>
+        </p:nvSpPr>
+        <p:spPr>
+          <a:xfrm>
+            <a:off x="146053" y="1229360"/>
+            <a:ext cx="63500" cy="431800"/>
           </a:xfrm>
           <a:prstGeom prst="rect">
             <a:avLst/>
@@ -21182,42 +21186,45 @@
           <a:solidFill>
             <a:srgbClr val="1565C0"/>
           </a:solidFill>
-          <a:ln w="0">
-            <a:noFill/>
-          </a:ln>
-        </p:spPr>
-        <p:txBody>
-          <a:bodyPr/>
-          <a:lstStyle/>
-          <a:p>
-            <a:endParaRPr lang="en-US"/>
-          </a:p>
-        </p:txBody>
-      </p:sp>
-      <p:sp>
-        <p:nvSpPr>
-          <p:cNvPr id="106" name="T106"/>
-          <p:cNvSpPr/>
-          <p:nvPr/>
-        </p:nvSpPr>
-        <p:spPr>
-          <a:xfrm>
-            <a:off x="558800" y="1346200"/>
-            <a:ext cx="1270000" cy="228600"/>
+          <a:ln>
+            <a:noFill/>
+          </a:ln>
+        </p:spPr>
+        <p:txBody>
+          <a:bodyPr wrap="square" lIns="36000" tIns="18000" rIns="36000" bIns="18000" anchor="ctr"/>
+          <a:lstStyle/>
+          <a:p>
+            <a:pPr algn="l">
+              <a:buNone/>
+            </a:pPr>
+            <a:endParaRPr/>
+          </a:p>
+        </p:txBody>
+      </p:sp>
+      <p:sp>
+        <p:nvSpPr>
+          <p:cNvPr id="106" name="S106"/>
+          <p:cNvSpPr/>
+          <p:nvPr/>
+        </p:nvSpPr>
+        <p:spPr>
+          <a:xfrm>
+            <a:off x="349253" y="1254760"/>
+            <a:ext cx="762000" cy="203200"/>
           </a:xfrm>
           <a:prstGeom prst="rect">
             <a:avLst/>
           </a:prstGeom>
           <a:noFill/>
-          <a:ln w="0">
-            <a:noFill/>
-          </a:ln>
-        </p:spPr>
-        <p:txBody>
-          <a:bodyPr wrap="square" lIns="0" tIns="0" rIns="0" bIns="0" anchor="t"/>
-          <a:lstStyle/>
-          <a:p>
-            <a:pPr>
+          <a:ln>
+            <a:noFill/>
+          </a:ln>
+        </p:spPr>
+        <p:txBody>
+          <a:bodyPr wrap="square" lIns="36000" tIns="18000" rIns="36000" bIns="18000" anchor="ctr"/>
+          <a:lstStyle/>
+          <a:p>
+            <a:pPr algn="l">
               <a:buNone/>
             </a:pPr>
             <a:r>
@@ -21234,38 +21241,38 @@
       </p:sp>
       <p:sp>
         <p:nvSpPr>
-          <p:cNvPr id="107" name="T107"/>
-          <p:cNvSpPr/>
-          <p:nvPr/>
-        </p:nvSpPr>
-        <p:spPr>
-          <a:xfrm>
-            <a:off x="558800" y="1574800"/>
-            <a:ext cx="4953000" cy="203200"/>
+          <p:cNvPr id="107" name="S107"/>
+          <p:cNvSpPr/>
+          <p:nvPr/>
+        </p:nvSpPr>
+        <p:spPr>
+          <a:xfrm>
+            <a:off x="349253" y="1445260"/>
+            <a:ext cx="5588000" cy="190500"/>
           </a:xfrm>
           <a:prstGeom prst="rect">
             <a:avLst/>
           </a:prstGeom>
           <a:noFill/>
-          <a:ln w="0">
-            <a:noFill/>
-          </a:ln>
-        </p:spPr>
-        <p:txBody>
-          <a:bodyPr wrap="square" lIns="0" tIns="0" rIns="0" bIns="0" anchor="t"/>
-          <a:lstStyle/>
-          <a:p>
-            <a:pPr>
-              <a:buNone/>
-            </a:pPr>
-            <a:r>
-              <a:rPr lang="en-US" sz="1200" dirty="0">
+          <a:ln>
+            <a:noFill/>
+          </a:ln>
+        </p:spPr>
+        <p:txBody>
+          <a:bodyPr wrap="square" lIns="36000" tIns="18000" rIns="36000" bIns="18000" anchor="ctr"/>
+          <a:lstStyle/>
+          <a:p>
+            <a:pPr algn="l">
+              <a:buNone/>
+            </a:pPr>
+            <a:r>
+              <a:rPr lang="en-US" sz="1000" dirty="0">
                 <a:solidFill>
                   <a:srgbClr val="64748B"/>
                 </a:solidFill>
                 <a:latin typeface="Aptos"/>
               </a:rPr>
-              <a:t>Sonnet default, Opus available</a:t>
+              <a:t>$17/mo — Sonnet default, Opus available</a:t>
             </a:r>
           </a:p>
         </p:txBody>
@@ -21278,46 +21285,44 @@
         </p:nvSpPr>
         <p:spPr>
           <a:xfrm>
-            <a:off x="381000" y="1854200"/>
-            <a:ext cx="5334000" cy="508000"/>
+            <a:off x="146053" y="1699260"/>
+            <a:ext cx="5714997" cy="431800"/>
           </a:xfrm>
           <a:prstGeom prst="roundRect">
             <a:avLst>
-              <a:gd name="adj" fmla="val 4000"/>
+              <a:gd name="adj" fmla="val 10000"/>
             </a:avLst>
           </a:prstGeom>
           <a:solidFill>
             <a:srgbClr val="F5F3FF"/>
           </a:solidFill>
-          <a:ln w="0">
-            <a:noFill/>
-          </a:ln>
-          <a:effectLst>
-            <a:outerShdw blurRad="25400" dist="12700" dir="5400000" algn="tl" rotWithShape="0">
-              <a:srgbClr val="000000">
-                <a:alpha val="10000"/>
-              </a:srgbClr>
-            </a:outerShdw>
-          </a:effectLst>
-        </p:spPr>
-        <p:txBody>
-          <a:bodyPr wrap="square" lIns="72000" tIns="54000" rIns="72000" bIns="54000" anchor="t"/>
-          <a:lstStyle/>
-          <a:p>
-            <a:endParaRPr lang="en-US"/>
-          </a:p>
-        </p:txBody>
-      </p:sp>
-      <p:sp>
-        <p:nvSpPr>
-          <p:cNvPr id="109" name="R109"/>
-          <p:cNvSpPr/>
-          <p:nvPr/>
-        </p:nvSpPr>
-        <p:spPr>
-          <a:xfrm>
-            <a:off x="381000" y="1854200"/>
-            <a:ext cx="50800" cy="508000"/>
+          <a:ln w="9525">
+            <a:solidFill>
+              <a:srgbClr val="7C3AED"/>
+            </a:solidFill>
+          </a:ln>
+        </p:spPr>
+        <p:txBody>
+          <a:bodyPr wrap="square" lIns="36000" tIns="18000" rIns="36000" bIns="18000" anchor="ctr"/>
+          <a:lstStyle/>
+          <a:p>
+            <a:pPr algn="l">
+              <a:buNone/>
+            </a:pPr>
+            <a:endParaRPr/>
+          </a:p>
+        </p:txBody>
+      </p:sp>
+      <p:sp>
+        <p:nvSpPr>
+          <p:cNvPr id="109" name="S109"/>
+          <p:cNvSpPr/>
+          <p:nvPr/>
+        </p:nvSpPr>
+        <p:spPr>
+          <a:xfrm>
+            <a:off x="146053" y="1699260"/>
+            <a:ext cx="63500" cy="431800"/>
           </a:xfrm>
           <a:prstGeom prst="rect">
             <a:avLst/>
@@ -21325,42 +21330,45 @@
           <a:solidFill>
             <a:srgbClr val="7C3AED"/>
           </a:solidFill>
-          <a:ln w="0">
-            <a:noFill/>
-          </a:ln>
-        </p:spPr>
-        <p:txBody>
-          <a:bodyPr/>
-          <a:lstStyle/>
-          <a:p>
-            <a:endParaRPr lang="en-US"/>
-          </a:p>
-        </p:txBody>
-      </p:sp>
-      <p:sp>
-        <p:nvSpPr>
-          <p:cNvPr id="110" name="T110"/>
-          <p:cNvSpPr/>
-          <p:nvPr/>
-        </p:nvSpPr>
-        <p:spPr>
-          <a:xfrm>
-            <a:off x="558800" y="1905000"/>
-            <a:ext cx="1270000" cy="228600"/>
+          <a:ln>
+            <a:noFill/>
+          </a:ln>
+        </p:spPr>
+        <p:txBody>
+          <a:bodyPr wrap="square" lIns="36000" tIns="18000" rIns="36000" bIns="18000" anchor="ctr"/>
+          <a:lstStyle/>
+          <a:p>
+            <a:pPr algn="l">
+              <a:buNone/>
+            </a:pPr>
+            <a:endParaRPr/>
+          </a:p>
+        </p:txBody>
+      </p:sp>
+      <p:sp>
+        <p:nvSpPr>
+          <p:cNvPr id="110" name="S110"/>
+          <p:cNvSpPr/>
+          <p:nvPr/>
+        </p:nvSpPr>
+        <p:spPr>
+          <a:xfrm>
+            <a:off x="349253" y="1724660"/>
+            <a:ext cx="762000" cy="203200"/>
           </a:xfrm>
           <a:prstGeom prst="rect">
             <a:avLst/>
           </a:prstGeom>
           <a:noFill/>
-          <a:ln w="0">
-            <a:noFill/>
-          </a:ln>
-        </p:spPr>
-        <p:txBody>
-          <a:bodyPr wrap="square" lIns="0" tIns="0" rIns="0" bIns="0" anchor="t"/>
-          <a:lstStyle/>
-          <a:p>
-            <a:pPr>
+          <a:ln>
+            <a:noFill/>
+          </a:ln>
+        </p:spPr>
+        <p:txBody>
+          <a:bodyPr wrap="square" lIns="36000" tIns="18000" rIns="36000" bIns="18000" anchor="ctr"/>
+          <a:lstStyle/>
+          <a:p>
+            <a:pPr algn="l">
               <a:buNone/>
             </a:pPr>
             <a:r>
@@ -21377,38 +21385,38 @@
       </p:sp>
       <p:sp>
         <p:nvSpPr>
-          <p:cNvPr id="111" name="T111"/>
-          <p:cNvSpPr/>
-          <p:nvPr/>
-        </p:nvSpPr>
-        <p:spPr>
-          <a:xfrm>
-            <a:off x="558800" y="2133600"/>
-            <a:ext cx="4953000" cy="203200"/>
+          <p:cNvPr id="111" name="S111"/>
+          <p:cNvSpPr/>
+          <p:nvPr/>
+        </p:nvSpPr>
+        <p:spPr>
+          <a:xfrm>
+            <a:off x="349253" y="1915160"/>
+            <a:ext cx="5588000" cy="190500"/>
           </a:xfrm>
           <a:prstGeom prst="rect">
             <a:avLst/>
           </a:prstGeom>
           <a:noFill/>
-          <a:ln w="0">
-            <a:noFill/>
-          </a:ln>
-        </p:spPr>
-        <p:txBody>
-          <a:bodyPr wrap="square" lIns="0" tIns="0" rIns="0" bIns="0" anchor="t"/>
-          <a:lstStyle/>
-          <a:p>
-            <a:pPr>
-              <a:buNone/>
-            </a:pPr>
-            <a:r>
-              <a:rPr lang="en-US" sz="1200" dirty="0">
+          <a:ln>
+            <a:noFill/>
+          </a:ln>
+        </p:spPr>
+        <p:txBody>
+          <a:bodyPr wrap="square" lIns="36000" tIns="18000" rIns="36000" bIns="18000" anchor="ctr"/>
+          <a:lstStyle/>
+          <a:p>
+            <a:pPr algn="l">
+              <a:buNone/>
+            </a:pPr>
+            <a:r>
+              <a:rPr lang="en-US" sz="1000" dirty="0">
                 <a:solidFill>
                   <a:srgbClr val="64748B"/>
                 </a:solidFill>
                 <a:latin typeface="Aptos"/>
               </a:rPr>
-              <a:t>Higher ceilings, priority features, Opus</a:t>
+              <a:t>$100/mo — 5× usage, priority Opus access</a:t>
             </a:r>
           </a:p>
         </p:txBody>
@@ -21421,46 +21429,44 @@
         </p:nvSpPr>
         <p:spPr>
           <a:xfrm>
-            <a:off x="381000" y="2413000"/>
-            <a:ext cx="5334000" cy="508000"/>
+            <a:off x="146053" y="2169160"/>
+            <a:ext cx="5714995" cy="431800"/>
           </a:xfrm>
           <a:prstGeom prst="roundRect">
             <a:avLst>
-              <a:gd name="adj" fmla="val 4000"/>
+              <a:gd name="adj" fmla="val 10000"/>
             </a:avLst>
           </a:prstGeom>
           <a:solidFill>
-            <a:srgbClr val="ECFDF5"/>
+            <a:srgbClr val="F0FDF4"/>
           </a:solidFill>
-          <a:ln w="0">
-            <a:noFill/>
-          </a:ln>
-          <a:effectLst>
-            <a:outerShdw blurRad="25400" dist="12700" dir="5400000" algn="tl" rotWithShape="0">
-              <a:srgbClr val="000000">
-                <a:alpha val="10000"/>
-              </a:srgbClr>
-            </a:outerShdw>
-          </a:effectLst>
-        </p:spPr>
-        <p:txBody>
-          <a:bodyPr wrap="square" lIns="72000" tIns="54000" rIns="72000" bIns="54000" anchor="t"/>
-          <a:lstStyle/>
-          <a:p>
-            <a:endParaRPr lang="en-US"/>
-          </a:p>
-        </p:txBody>
-      </p:sp>
-      <p:sp>
-        <p:nvSpPr>
-          <p:cNvPr id="113" name="R113"/>
-          <p:cNvSpPr/>
-          <p:nvPr/>
-        </p:nvSpPr>
-        <p:spPr>
-          <a:xfrm>
-            <a:off x="381000" y="2413000"/>
-            <a:ext cx="50800" cy="508000"/>
+          <a:ln w="9525">
+            <a:solidFill>
+              <a:srgbClr val="059669"/>
+            </a:solidFill>
+          </a:ln>
+        </p:spPr>
+        <p:txBody>
+          <a:bodyPr wrap="square" lIns="36000" tIns="18000" rIns="36000" bIns="18000" anchor="ctr"/>
+          <a:lstStyle/>
+          <a:p>
+            <a:pPr algn="l">
+              <a:buNone/>
+            </a:pPr>
+            <a:endParaRPr/>
+          </a:p>
+        </p:txBody>
+      </p:sp>
+      <p:sp>
+        <p:nvSpPr>
+          <p:cNvPr id="113" name="S113"/>
+          <p:cNvSpPr/>
+          <p:nvPr/>
+        </p:nvSpPr>
+        <p:spPr>
+          <a:xfrm>
+            <a:off x="146053" y="2169160"/>
+            <a:ext cx="63500" cy="431800"/>
           </a:xfrm>
           <a:prstGeom prst="rect">
             <a:avLst/>
@@ -21468,42 +21474,45 @@
           <a:solidFill>
             <a:srgbClr val="059669"/>
           </a:solidFill>
-          <a:ln w="0">
-            <a:noFill/>
-          </a:ln>
-        </p:spPr>
-        <p:txBody>
-          <a:bodyPr/>
-          <a:lstStyle/>
-          <a:p>
-            <a:endParaRPr lang="en-US"/>
-          </a:p>
-        </p:txBody>
-      </p:sp>
-      <p:sp>
-        <p:nvSpPr>
-          <p:cNvPr id="114" name="T114"/>
-          <p:cNvSpPr/>
-          <p:nvPr/>
-        </p:nvSpPr>
-        <p:spPr>
-          <a:xfrm>
-            <a:off x="558800" y="2463800"/>
-            <a:ext cx="1270000" cy="228600"/>
+          <a:ln>
+            <a:noFill/>
+          </a:ln>
+        </p:spPr>
+        <p:txBody>
+          <a:bodyPr wrap="square" lIns="36000" tIns="18000" rIns="36000" bIns="18000" anchor="ctr"/>
+          <a:lstStyle/>
+          <a:p>
+            <a:pPr algn="l">
+              <a:buNone/>
+            </a:pPr>
+            <a:endParaRPr/>
+          </a:p>
+        </p:txBody>
+      </p:sp>
+      <p:sp>
+        <p:nvSpPr>
+          <p:cNvPr id="114" name="S114"/>
+          <p:cNvSpPr/>
+          <p:nvPr/>
+        </p:nvSpPr>
+        <p:spPr>
+          <a:xfrm>
+            <a:off x="349253" y="2194560"/>
+            <a:ext cx="762000" cy="203200"/>
           </a:xfrm>
           <a:prstGeom prst="rect">
             <a:avLst/>
           </a:prstGeom>
           <a:noFill/>
-          <a:ln w="0">
-            <a:noFill/>
-          </a:ln>
-        </p:spPr>
-        <p:txBody>
-          <a:bodyPr wrap="square" lIns="0" tIns="0" rIns="0" bIns="0" anchor="t"/>
-          <a:lstStyle/>
-          <a:p>
-            <a:pPr>
+          <a:ln>
+            <a:noFill/>
+          </a:ln>
+        </p:spPr>
+        <p:txBody>
+          <a:bodyPr wrap="square" lIns="36000" tIns="18000" rIns="36000" bIns="18000" anchor="ctr"/>
+          <a:lstStyle/>
+          <a:p>
+            <a:pPr algn="l">
               <a:buNone/>
             </a:pPr>
             <a:r>
@@ -21520,38 +21529,38 @@
       </p:sp>
       <p:sp>
         <p:nvSpPr>
-          <p:cNvPr id="115" name="T115"/>
-          <p:cNvSpPr/>
-          <p:nvPr/>
-        </p:nvSpPr>
-        <p:spPr>
-          <a:xfrm>
-            <a:off x="558800" y="2692400"/>
-            <a:ext cx="4953000" cy="203200"/>
+          <p:cNvPr id="115" name="S115"/>
+          <p:cNvSpPr/>
+          <p:nvPr/>
+        </p:nvSpPr>
+        <p:spPr>
+          <a:xfrm>
+            <a:off x="349253" y="2385060"/>
+            <a:ext cx="5588000" cy="190500"/>
           </a:xfrm>
           <a:prstGeom prst="rect">
             <a:avLst/>
           </a:prstGeom>
           <a:noFill/>
-          <a:ln w="0">
-            <a:noFill/>
-          </a:ln>
-        </p:spPr>
-        <p:txBody>
-          <a:bodyPr wrap="square" lIns="0" tIns="0" rIns="0" bIns="0" anchor="t"/>
-          <a:lstStyle/>
-          <a:p>
-            <a:pPr>
-              <a:buNone/>
-            </a:pPr>
-            <a:r>
-              <a:rPr lang="en-US" sz="1200" dirty="0">
+          <a:ln>
+            <a:noFill/>
+          </a:ln>
+        </p:spPr>
+        <p:txBody>
+          <a:bodyPr wrap="square" lIns="36000" tIns="18000" rIns="36000" bIns="18000" anchor="ctr"/>
+          <a:lstStyle/>
+          <a:p>
+            <a:pPr algn="l">
+              <a:buNone/>
+            </a:pPr>
+            <a:r>
+              <a:rPr lang="en-US" sz="1000" dirty="0">
                 <a:solidFill>
                   <a:srgbClr val="64748B"/>
                 </a:solidFill>
                 <a:latin typeface="Aptos"/>
               </a:rPr>
-              <a:t>Multi-user, admin controls, Opus</a:t>
+              <a:t>$30/user/mo — Multi-user, admin controls, Opus</a:t>
             </a:r>
           </a:p>
         </p:txBody>
@@ -21564,46 +21573,44 @@
         </p:nvSpPr>
         <p:spPr>
           <a:xfrm>
-            <a:off x="381000" y="2971800"/>
-            <a:ext cx="5334000" cy="508000"/>
+            <a:off x="146053" y="2639060"/>
+            <a:ext cx="5714994" cy="431800"/>
           </a:xfrm>
           <a:prstGeom prst="roundRect">
             <a:avLst>
-              <a:gd name="adj" fmla="val 4000"/>
+              <a:gd name="adj" fmla="val 10000"/>
             </a:avLst>
           </a:prstGeom>
           <a:solidFill>
             <a:srgbClr val="FFF7ED"/>
           </a:solidFill>
-          <a:ln w="0">
-            <a:noFill/>
-          </a:ln>
-          <a:effectLst>
-            <a:outerShdw blurRad="25400" dist="12700" dir="5400000" algn="tl" rotWithShape="0">
-              <a:srgbClr val="000000">
-                <a:alpha val="10000"/>
-              </a:srgbClr>
-            </a:outerShdw>
-          </a:effectLst>
-        </p:spPr>
-        <p:txBody>
-          <a:bodyPr wrap="square" lIns="72000" tIns="54000" rIns="72000" bIns="54000" anchor="t"/>
-          <a:lstStyle/>
-          <a:p>
-            <a:endParaRPr lang="en-US"/>
-          </a:p>
-        </p:txBody>
-      </p:sp>
-      <p:sp>
-        <p:nvSpPr>
-          <p:cNvPr id="117" name="R117"/>
-          <p:cNvSpPr/>
-          <p:nvPr/>
-        </p:nvSpPr>
-        <p:spPr>
-          <a:xfrm>
-            <a:off x="381000" y="2971800"/>
-            <a:ext cx="50800" cy="508000"/>
+          <a:ln w="9525">
+            <a:solidFill>
+              <a:srgbClr val="D4622B"/>
+            </a:solidFill>
+          </a:ln>
+        </p:spPr>
+        <p:txBody>
+          <a:bodyPr wrap="square" lIns="36000" tIns="18000" rIns="36000" bIns="18000" anchor="ctr"/>
+          <a:lstStyle/>
+          <a:p>
+            <a:pPr algn="l">
+              <a:buNone/>
+            </a:pPr>
+            <a:endParaRPr/>
+          </a:p>
+        </p:txBody>
+      </p:sp>
+      <p:sp>
+        <p:nvSpPr>
+          <p:cNvPr id="117" name="S117"/>
+          <p:cNvSpPr/>
+          <p:nvPr/>
+        </p:nvSpPr>
+        <p:spPr>
+          <a:xfrm>
+            <a:off x="146053" y="2639060"/>
+            <a:ext cx="63500" cy="431800"/>
           </a:xfrm>
           <a:prstGeom prst="rect">
             <a:avLst/>
@@ -21611,42 +21618,45 @@
           <a:solidFill>
             <a:srgbClr val="D4622B"/>
           </a:solidFill>
-          <a:ln w="0">
-            <a:noFill/>
-          </a:ln>
-        </p:spPr>
-        <p:txBody>
-          <a:bodyPr/>
-          <a:lstStyle/>
-          <a:p>
-            <a:endParaRPr lang="en-US"/>
-          </a:p>
-        </p:txBody>
-      </p:sp>
-      <p:sp>
-        <p:nvSpPr>
-          <p:cNvPr id="118" name="T118"/>
-          <p:cNvSpPr/>
-          <p:nvPr/>
-        </p:nvSpPr>
-        <p:spPr>
-          <a:xfrm>
-            <a:off x="558800" y="3022600"/>
-            <a:ext cx="1270000" cy="228600"/>
+          <a:ln>
+            <a:noFill/>
+          </a:ln>
+        </p:spPr>
+        <p:txBody>
+          <a:bodyPr wrap="square" lIns="36000" tIns="18000" rIns="36000" bIns="18000" anchor="ctr"/>
+          <a:lstStyle/>
+          <a:p>
+            <a:pPr algn="l">
+              <a:buNone/>
+            </a:pPr>
+            <a:endParaRPr/>
+          </a:p>
+        </p:txBody>
+      </p:sp>
+      <p:sp>
+        <p:nvSpPr>
+          <p:cNvPr id="118" name="S118"/>
+          <p:cNvSpPr/>
+          <p:nvPr/>
+        </p:nvSpPr>
+        <p:spPr>
+          <a:xfrm>
+            <a:off x="349253" y="2664460"/>
+            <a:ext cx="762000" cy="203200"/>
           </a:xfrm>
           <a:prstGeom prst="rect">
             <a:avLst/>
           </a:prstGeom>
           <a:noFill/>
-          <a:ln w="0">
-            <a:noFill/>
-          </a:ln>
-        </p:spPr>
-        <p:txBody>
-          <a:bodyPr wrap="square" lIns="0" tIns="0" rIns="0" bIns="0" anchor="t"/>
-          <a:lstStyle/>
-          <a:p>
-            <a:pPr>
+          <a:ln>
+            <a:noFill/>
+          </a:ln>
+        </p:spPr>
+        <p:txBody>
+          <a:bodyPr wrap="square" lIns="36000" tIns="18000" rIns="36000" bIns="18000" anchor="ctr"/>
+          <a:lstStyle/>
+          <a:p>
+            <a:pPr algn="l">
               <a:buNone/>
             </a:pPr>
             <a:r>
@@ -21663,66 +21673,66 @@
       </p:sp>
       <p:sp>
         <p:nvSpPr>
-          <p:cNvPr id="119" name="T119"/>
-          <p:cNvSpPr/>
-          <p:nvPr/>
-        </p:nvSpPr>
-        <p:spPr>
-          <a:xfrm>
-            <a:off x="558800" y="3251200"/>
-            <a:ext cx="4953000" cy="203200"/>
+          <p:cNvPr id="119" name="S119"/>
+          <p:cNvSpPr/>
+          <p:nvPr/>
+        </p:nvSpPr>
+        <p:spPr>
+          <a:xfrm>
+            <a:off x="349253" y="2854960"/>
+            <a:ext cx="5588000" cy="190500"/>
           </a:xfrm>
           <a:prstGeom prst="rect">
             <a:avLst/>
           </a:prstGeom>
           <a:noFill/>
-          <a:ln w="0">
-            <a:noFill/>
-          </a:ln>
-        </p:spPr>
-        <p:txBody>
-          <a:bodyPr wrap="square" lIns="0" tIns="0" rIns="0" bIns="0" anchor="t"/>
-          <a:lstStyle/>
-          <a:p>
-            <a:pPr>
-              <a:buNone/>
-            </a:pPr>
-            <a:r>
-              <a:rPr lang="en-US" sz="1200" dirty="0">
+          <a:ln>
+            <a:noFill/>
+          </a:ln>
+        </p:spPr>
+        <p:txBody>
+          <a:bodyPr wrap="square" lIns="36000" tIns="18000" rIns="36000" bIns="18000" anchor="ctr"/>
+          <a:lstStyle/>
+          <a:p>
+            <a:pPr algn="l">
+              <a:buNone/>
+            </a:pPr>
+            <a:r>
+              <a:rPr lang="en-US" sz="1000" dirty="0">
                 <a:solidFill>
                   <a:srgbClr val="64748B"/>
                 </a:solidFill>
                 <a:latin typeface="Aptos"/>
               </a:rPr>
-              <a:t>SSO, RBAC, compliance, managed policies</a:t>
-            </a:r>
-          </a:p>
-        </p:txBody>
-      </p:sp>
-      <p:sp>
-        <p:nvSpPr>
-          <p:cNvPr id="120" name="T120"/>
-          <p:cNvSpPr/>
-          <p:nvPr/>
-        </p:nvSpPr>
-        <p:spPr>
-          <a:xfrm>
-            <a:off x="6096000" y="1041400"/>
+              <a:t>Custom — SSO, RBAC, compliance, managed policies</a:t>
+            </a:r>
+          </a:p>
+        </p:txBody>
+      </p:sp>
+      <p:sp>
+        <p:nvSpPr>
+          <p:cNvPr id="120" name="S120"/>
+          <p:cNvSpPr/>
+          <p:nvPr/>
+        </p:nvSpPr>
+        <p:spPr>
+          <a:xfrm>
+            <a:off x="381000" y="3149600"/>
             <a:ext cx="2540000" cy="203200"/>
           </a:xfrm>
           <a:prstGeom prst="rect">
             <a:avLst/>
           </a:prstGeom>
           <a:noFill/>
-          <a:ln w="0">
-            <a:noFill/>
-          </a:ln>
-        </p:spPr>
-        <p:txBody>
-          <a:bodyPr wrap="square" lIns="0" tIns="0" rIns="0" bIns="0" anchor="t"/>
-          <a:lstStyle/>
-          <a:p>
-            <a:pPr>
+          <a:ln>
+            <a:noFill/>
+          </a:ln>
+        </p:spPr>
+        <p:txBody>
+          <a:bodyPr wrap="square" lIns="36000" tIns="18000" rIns="36000" bIns="18000" anchor="ctr"/>
+          <a:lstStyle/>
+          <a:p>
+            <a:pPr algn="l">
               <a:buNone/>
             </a:pPr>
             <a:r>
@@ -21745,46 +21755,44 @@
         </p:nvSpPr>
         <p:spPr>
           <a:xfrm>
-            <a:off x="6096000" y="1295400"/>
-            <a:ext cx="1905000" cy="2184400"/>
+            <a:off x="177800" y="3403600"/>
+            <a:ext cx="1828800" cy="2603500"/>
           </a:xfrm>
           <a:prstGeom prst="roundRect">
             <a:avLst>
-              <a:gd name="adj" fmla="val 5000"/>
+              <a:gd name="adj" fmla="val 10000"/>
             </a:avLst>
           </a:prstGeom>
           <a:solidFill>
             <a:srgbClr val="F0F9FF"/>
           </a:solidFill>
-          <a:ln w="0">
-            <a:noFill/>
-          </a:ln>
-          <a:effectLst>
-            <a:outerShdw blurRad="25400" dist="12700" dir="5400000" algn="tl" rotWithShape="0">
-              <a:srgbClr val="000000">
-                <a:alpha val="10000"/>
-              </a:srgbClr>
-            </a:outerShdw>
-          </a:effectLst>
-        </p:spPr>
-        <p:txBody>
-          <a:bodyPr wrap="square" lIns="72000" tIns="54000" rIns="72000" bIns="54000" anchor="t"/>
-          <a:lstStyle/>
-          <a:p>
-            <a:endParaRPr lang="en-US"/>
-          </a:p>
-        </p:txBody>
-      </p:sp>
-      <p:sp>
-        <p:nvSpPr>
-          <p:cNvPr id="122" name="R122"/>
-          <p:cNvSpPr/>
-          <p:nvPr/>
-        </p:nvSpPr>
-        <p:spPr>
-          <a:xfrm>
-            <a:off x="6096000" y="1295400"/>
-            <a:ext cx="1905000" cy="50800"/>
+          <a:ln w="9525">
+            <a:solidFill>
+              <a:srgbClr val="0EA5E9"/>
+            </a:solidFill>
+          </a:ln>
+        </p:spPr>
+        <p:txBody>
+          <a:bodyPr wrap="square" lIns="36000" tIns="18000" rIns="36000" bIns="18000" anchor="t"/>
+          <a:lstStyle/>
+          <a:p>
+            <a:pPr algn="ctr">
+              <a:buNone/>
+            </a:pPr>
+            <a:endParaRPr/>
+          </a:p>
+        </p:txBody>
+      </p:sp>
+      <p:sp>
+        <p:nvSpPr>
+          <p:cNvPr id="122" name="S122"/>
+          <p:cNvSpPr/>
+          <p:nvPr/>
+        </p:nvSpPr>
+        <p:spPr>
+          <a:xfrm>
+            <a:off x="177800" y="3403600"/>
+            <a:ext cx="1828800" cy="91440"/>
           </a:xfrm>
           <a:prstGeom prst="rect">
             <a:avLst/>
@@ -21792,39 +21800,42 @@
           <a:solidFill>
             <a:srgbClr val="0EA5E9"/>
           </a:solidFill>
-          <a:ln w="0">
-            <a:noFill/>
-          </a:ln>
-        </p:spPr>
-        <p:txBody>
-          <a:bodyPr/>
-          <a:lstStyle/>
-          <a:p>
-            <a:endParaRPr lang="en-US"/>
-          </a:p>
-        </p:txBody>
-      </p:sp>
-      <p:sp>
-        <p:nvSpPr>
-          <p:cNvPr id="123" name="T123"/>
-          <p:cNvSpPr/>
-          <p:nvPr/>
-        </p:nvSpPr>
-        <p:spPr>
-          <a:xfrm>
-            <a:off x="6223000" y="1473200"/>
-            <a:ext cx="1651000" cy="254000"/>
+          <a:ln>
+            <a:noFill/>
+          </a:ln>
+        </p:spPr>
+        <p:txBody>
+          <a:bodyPr wrap="square" lIns="36000" tIns="18000" rIns="36000" bIns="18000" anchor="ctr"/>
+          <a:lstStyle/>
+          <a:p>
+            <a:pPr algn="l">
+              <a:buNone/>
+            </a:pPr>
+            <a:endParaRPr/>
+          </a:p>
+        </p:txBody>
+      </p:sp>
+      <p:sp>
+        <p:nvSpPr>
+          <p:cNvPr id="123" name="S123"/>
+          <p:cNvSpPr/>
+          <p:nvPr/>
+        </p:nvSpPr>
+        <p:spPr>
+          <a:xfrm>
+            <a:off x="279400" y="3581400"/>
+            <a:ext cx="1727200" cy="279400"/>
           </a:xfrm>
           <a:prstGeom prst="rect">
             <a:avLst/>
           </a:prstGeom>
           <a:noFill/>
-          <a:ln w="0">
-            <a:noFill/>
-          </a:ln>
-        </p:spPr>
-        <p:txBody>
-          <a:bodyPr wrap="square" lIns="0" tIns="0" rIns="0" bIns="0" anchor="t"/>
+          <a:ln>
+            <a:noFill/>
+          </a:ln>
+        </p:spPr>
+        <p:txBody>
+          <a:bodyPr wrap="square" lIns="36000" tIns="18000" rIns="36000" bIns="18000" anchor="ctr"/>
           <a:lstStyle/>
           <a:p>
             <a:pPr algn="ctr">
@@ -21844,25 +21855,25 @@
       </p:sp>
       <p:sp>
         <p:nvSpPr>
-          <p:cNvPr id="124" name="T124"/>
-          <p:cNvSpPr/>
-          <p:nvPr/>
-        </p:nvSpPr>
-        <p:spPr>
-          <a:xfrm>
-            <a:off x="6223000" y="1752600"/>
-            <a:ext cx="1651000" cy="228600"/>
+          <p:cNvPr id="124" name="S124"/>
+          <p:cNvSpPr/>
+          <p:nvPr/>
+        </p:nvSpPr>
+        <p:spPr>
+          <a:xfrm>
+            <a:off x="279400" y="3860800"/>
+            <a:ext cx="1727200" cy="228600"/>
           </a:xfrm>
           <a:prstGeom prst="rect">
             <a:avLst/>
           </a:prstGeom>
           <a:noFill/>
-          <a:ln w="0">
-            <a:noFill/>
-          </a:ln>
-        </p:spPr>
-        <p:txBody>
-          <a:bodyPr wrap="square" lIns="0" tIns="0" rIns="0" bIns="0" anchor="t"/>
+          <a:ln>
+            <a:noFill/>
+          </a:ln>
+        </p:spPr>
+        <p:txBody>
+          <a:bodyPr wrap="square" lIns="36000" tIns="18000" rIns="36000" bIns="18000" anchor="ctr"/>
           <a:lstStyle/>
           <a:p>
             <a:pPr algn="ctr">
@@ -21888,105 +21899,103 @@
         </p:nvCxnSpPr>
         <p:spPr>
           <a:xfrm>
-            <a:off x="6273800" y="2032000"/>
-            <a:ext cx="1549400" cy="0"/>
-          </a:xfrm>
-          <a:prstGeom prst="straightConnector1">
-            <a:avLst/>
-          </a:prstGeom>
+            <a:off x="177800" y="4140200"/>
+            <a:ext cx="1524000" cy="0"/>
+          </a:xfrm>
+          <a:prstGeom prst="line">
+            <a:avLst/>
+          </a:prstGeom>
+          <a:ln w="6350">
+            <a:solidFill>
+              <a:srgbClr val="E2E8F0"/>
+            </a:solidFill>
+          </a:ln>
+        </p:spPr>
+      </p:cxnSp>
+      <p:sp>
+        <p:nvSpPr>
+          <p:cNvPr id="126" name="S126"/>
+          <p:cNvSpPr/>
+          <p:nvPr/>
+        </p:nvSpPr>
+        <p:spPr>
+          <a:xfrm>
+            <a:off x="279400" y="4216400"/>
+            <a:ext cx="1727200" cy="1663700"/>
+          </a:xfrm>
+          <a:prstGeom prst="rect">
+            <a:avLst/>
+          </a:prstGeom>
+          <a:noFill/>
+          <a:ln>
+            <a:noFill/>
+          </a:ln>
+        </p:spPr>
+        <p:txBody>
+          <a:bodyPr wrap="square" lIns="36000" tIns="18000" rIns="36000" bIns="18000" anchor="t"/>
+          <a:lstStyle/>
+          <a:p>
+            <a:pPr algn="ctr">
+              <a:buNone/>
+            </a:pPr>
+            <a:r>
+              <a:rPr lang="en-US" sz="1100" dirty="0">
+                <a:solidFill>
+                  <a:srgbClr val="475569"/>
+                </a:solidFill>
+                <a:latin typeface="Aptos"/>
+              </a:rPr>
+              <a:t>Fastest, most cost-efficient. Ideal for subagents, rapid prototyping, log scanning, and parallel tasks.</a:t>
+            </a:r>
+          </a:p>
+        </p:txBody>
+      </p:sp>
+      <p:sp>
+        <p:nvSpPr>
+          <p:cNvPr id="127" name="S127"/>
+          <p:cNvSpPr/>
+          <p:nvPr/>
+        </p:nvSpPr>
+        <p:spPr>
+          <a:xfrm>
+            <a:off x="2265680" y="3403600"/>
+            <a:ext cx="1803400" cy="2603500"/>
+          </a:xfrm>
+          <a:prstGeom prst="roundRect">
+            <a:avLst>
+              <a:gd name="adj" fmla="val 10000"/>
+            </a:avLst>
+          </a:prstGeom>
+          <a:solidFill>
+            <a:srgbClr val="EFF6FF"/>
+          </a:solidFill>
           <a:ln w="9525">
             <a:solidFill>
-              <a:srgbClr val="0EA5E9"/>
+              <a:srgbClr val="1565C0"/>
             </a:solidFill>
           </a:ln>
         </p:spPr>
-      </p:cxnSp>
-      <p:sp>
-        <p:nvSpPr>
-          <p:cNvPr id="126" name="T126"/>
-          <p:cNvSpPr/>
-          <p:nvPr/>
-        </p:nvSpPr>
-        <p:spPr>
-          <a:xfrm>
-            <a:off x="6223000" y="2133600"/>
-            <a:ext cx="1651000" cy="1244600"/>
-          </a:xfrm>
-          <a:prstGeom prst="rect">
-            <a:avLst/>
-          </a:prstGeom>
-          <a:noFill/>
-          <a:ln w="0">
-            <a:noFill/>
-          </a:ln>
-        </p:spPr>
-        <p:txBody>
-          <a:bodyPr wrap="square" lIns="0" tIns="0" rIns="0" bIns="0" anchor="t"/>
+        <p:txBody>
+          <a:bodyPr wrap="square" lIns="36000" tIns="18000" rIns="36000" bIns="18000" anchor="t"/>
           <a:lstStyle/>
           <a:p>
             <a:pPr algn="ctr">
               <a:buNone/>
             </a:pPr>
-            <a:r>
-              <a:rPr lang="en-US" sz="1200" dirty="0">
-                <a:solidFill>
-                  <a:srgbClr val="475569"/>
-                </a:solidFill>
-                <a:latin typeface="Aptos"/>
-              </a:rPr>
-              <a:t>Fastest, most cost-efficient. Ideal for subagents, rapid prototyping, log summarization, and parallel investigations.</a:t>
-            </a:r>
-          </a:p>
-        </p:txBody>
-      </p:sp>
-      <p:sp>
-        <p:nvSpPr>
-          <p:cNvPr id="127" name="S127"/>
-          <p:cNvSpPr/>
-          <p:nvPr/>
-        </p:nvSpPr>
-        <p:spPr>
-          <a:xfrm>
-            <a:off x="8077200" y="1295400"/>
-            <a:ext cx="1905000" cy="2184400"/>
-          </a:xfrm>
-          <a:prstGeom prst="roundRect">
-            <a:avLst>
-              <a:gd name="adj" fmla="val 5000"/>
-            </a:avLst>
-          </a:prstGeom>
-          <a:solidFill>
-            <a:srgbClr val="EBF5FF"/>
-          </a:solidFill>
-          <a:ln w="0">
-            <a:noFill/>
-          </a:ln>
-          <a:effectLst>
-            <a:outerShdw blurRad="25400" dist="12700" dir="5400000" algn="tl" rotWithShape="0">
-              <a:srgbClr val="000000">
-                <a:alpha val="10000"/>
-              </a:srgbClr>
-            </a:outerShdw>
-          </a:effectLst>
-        </p:spPr>
-        <p:txBody>
-          <a:bodyPr wrap="square" lIns="72000" tIns="54000" rIns="72000" bIns="54000" anchor="t"/>
-          <a:lstStyle/>
-          <a:p>
-            <a:endParaRPr lang="en-US"/>
-          </a:p>
-        </p:txBody>
-      </p:sp>
-      <p:sp>
-        <p:nvSpPr>
-          <p:cNvPr id="128" name="R128"/>
-          <p:cNvSpPr/>
-          <p:nvPr/>
-        </p:nvSpPr>
-        <p:spPr>
-          <a:xfrm>
-            <a:off x="8077200" y="1295400"/>
-            <a:ext cx="1905000" cy="50800"/>
+            <a:endParaRPr/>
+          </a:p>
+        </p:txBody>
+      </p:sp>
+      <p:sp>
+        <p:nvSpPr>
+          <p:cNvPr id="128" name="S128"/>
+          <p:cNvSpPr/>
+          <p:nvPr/>
+        </p:nvSpPr>
+        <p:spPr>
+          <a:xfrm>
+            <a:off x="2270758" y="3403600"/>
+            <a:ext cx="1803401" cy="76200"/>
           </a:xfrm>
           <a:prstGeom prst="rect">
             <a:avLst/>
@@ -21994,39 +22003,42 @@
           <a:solidFill>
             <a:srgbClr val="1565C0"/>
           </a:solidFill>
-          <a:ln w="0">
-            <a:noFill/>
-          </a:ln>
-        </p:spPr>
-        <p:txBody>
-          <a:bodyPr/>
-          <a:lstStyle/>
-          <a:p>
-            <a:endParaRPr lang="en-US"/>
-          </a:p>
-        </p:txBody>
-      </p:sp>
-      <p:sp>
-        <p:nvSpPr>
-          <p:cNvPr id="129" name="T129"/>
-          <p:cNvSpPr/>
-          <p:nvPr/>
-        </p:nvSpPr>
-        <p:spPr>
-          <a:xfrm>
-            <a:off x="8204200" y="1473200"/>
-            <a:ext cx="1651000" cy="254000"/>
+          <a:ln>
+            <a:noFill/>
+          </a:ln>
+        </p:spPr>
+        <p:txBody>
+          <a:bodyPr wrap="square" lIns="36000" tIns="18000" rIns="36000" bIns="18000" anchor="ctr"/>
+          <a:lstStyle/>
+          <a:p>
+            <a:pPr algn="l">
+              <a:buNone/>
+            </a:pPr>
+            <a:endParaRPr/>
+          </a:p>
+        </p:txBody>
+      </p:sp>
+      <p:sp>
+        <p:nvSpPr>
+          <p:cNvPr id="129" name="S129"/>
+          <p:cNvSpPr/>
+          <p:nvPr/>
+        </p:nvSpPr>
+        <p:spPr>
+          <a:xfrm>
+            <a:off x="2265680" y="3581400"/>
+            <a:ext cx="1727200" cy="279400"/>
           </a:xfrm>
           <a:prstGeom prst="rect">
             <a:avLst/>
           </a:prstGeom>
           <a:noFill/>
-          <a:ln w="0">
-            <a:noFill/>
-          </a:ln>
-        </p:spPr>
-        <p:txBody>
-          <a:bodyPr wrap="square" lIns="0" tIns="0" rIns="0" bIns="0" anchor="t"/>
+          <a:ln>
+            <a:noFill/>
+          </a:ln>
+        </p:spPr>
+        <p:txBody>
+          <a:bodyPr wrap="square" lIns="36000" tIns="18000" rIns="36000" bIns="18000" anchor="ctr"/>
           <a:lstStyle/>
           <a:p>
             <a:pPr algn="ctr">
@@ -22046,25 +22058,25 @@
       </p:sp>
       <p:sp>
         <p:nvSpPr>
-          <p:cNvPr id="130" name="T130"/>
-          <p:cNvSpPr/>
-          <p:nvPr/>
-        </p:nvSpPr>
-        <p:spPr>
-          <a:xfrm>
-            <a:off x="8204200" y="1752600"/>
-            <a:ext cx="1651000" cy="228600"/>
+          <p:cNvPr id="130" name="S130"/>
+          <p:cNvSpPr/>
+          <p:nvPr/>
+        </p:nvSpPr>
+        <p:spPr>
+          <a:xfrm>
+            <a:off x="2265680" y="3860800"/>
+            <a:ext cx="1727200" cy="228600"/>
           </a:xfrm>
           <a:prstGeom prst="rect">
             <a:avLst/>
           </a:prstGeom>
           <a:noFill/>
-          <a:ln w="0">
-            <a:noFill/>
-          </a:ln>
-        </p:spPr>
-        <p:txBody>
-          <a:bodyPr wrap="square" lIns="0" tIns="0" rIns="0" bIns="0" anchor="t"/>
+          <a:ln>
+            <a:noFill/>
+          </a:ln>
+        </p:spPr>
+        <p:txBody>
+          <a:bodyPr wrap="square" lIns="36000" tIns="18000" rIns="36000" bIns="18000" anchor="ctr"/>
           <a:lstStyle/>
           <a:p>
             <a:pPr algn="ctr">
@@ -22090,53 +22102,53 @@
         </p:nvCxnSpPr>
         <p:spPr>
           <a:xfrm>
-            <a:off x="8255000" y="2032000"/>
-            <a:ext cx="1549400" cy="0"/>
-          </a:xfrm>
-          <a:prstGeom prst="straightConnector1">
-            <a:avLst/>
-          </a:prstGeom>
-          <a:ln w="9525">
+            <a:off x="2367280" y="4140200"/>
+            <a:ext cx="1524000" cy="0"/>
+          </a:xfrm>
+          <a:prstGeom prst="line">
+            <a:avLst/>
+          </a:prstGeom>
+          <a:ln w="6350">
             <a:solidFill>
-              <a:srgbClr val="1565C0"/>
+              <a:srgbClr val="E2E8F0"/>
             </a:solidFill>
           </a:ln>
         </p:spPr>
       </p:cxnSp>
       <p:sp>
         <p:nvSpPr>
-          <p:cNvPr id="132" name="T132"/>
-          <p:cNvSpPr/>
-          <p:nvPr/>
-        </p:nvSpPr>
-        <p:spPr>
-          <a:xfrm>
-            <a:off x="8204200" y="2133600"/>
-            <a:ext cx="1651000" cy="1244600"/>
+          <p:cNvPr id="132" name="S132"/>
+          <p:cNvSpPr/>
+          <p:nvPr/>
+        </p:nvSpPr>
+        <p:spPr>
+          <a:xfrm>
+            <a:off x="2265680" y="4216400"/>
+            <a:ext cx="1727200" cy="1663700"/>
           </a:xfrm>
           <a:prstGeom prst="rect">
             <a:avLst/>
           </a:prstGeom>
           <a:noFill/>
-          <a:ln w="0">
-            <a:noFill/>
-          </a:ln>
-        </p:spPr>
-        <p:txBody>
-          <a:bodyPr wrap="square" lIns="0" tIns="0" rIns="0" bIns="0" anchor="t"/>
+          <a:ln>
+            <a:noFill/>
+          </a:ln>
+        </p:spPr>
+        <p:txBody>
+          <a:bodyPr wrap="square" lIns="36000" tIns="18000" rIns="36000" bIns="18000" anchor="t"/>
           <a:lstStyle/>
           <a:p>
             <a:pPr algn="ctr">
               <a:buNone/>
             </a:pPr>
             <a:r>
-              <a:rPr lang="en-US" sz="1200" dirty="0">
+              <a:rPr lang="en-US" sz="1100" dirty="0">
                 <a:solidFill>
                   <a:srgbClr val="475569"/>
                 </a:solidFill>
                 <a:latin typeface="Aptos"/>
               </a:rPr>
-              <a:t>Frontier coding, planning, and knowledge work. Handles most tasks well. Default for Pro. Best everyday builder.</a:t>
+              <a:t>Frontier coding, planning, knowledge work. Handles most tasks well. Default for Pro. Best everyday builder.</a:t>
             </a:r>
           </a:p>
         </p:txBody>
@@ -22149,46 +22161,44 @@
         </p:nvSpPr>
         <p:spPr>
           <a:xfrm>
-            <a:off x="10058400" y="1295400"/>
-            <a:ext cx="1905000" cy="2184400"/>
+            <a:off x="4292600" y="3403600"/>
+            <a:ext cx="1803398" cy="2603500"/>
           </a:xfrm>
           <a:prstGeom prst="roundRect">
             <a:avLst>
-              <a:gd name="adj" fmla="val 5000"/>
+              <a:gd name="adj" fmla="val 10000"/>
             </a:avLst>
           </a:prstGeom>
           <a:solidFill>
             <a:srgbClr val="F5F3FF"/>
           </a:solidFill>
-          <a:ln w="0">
-            <a:noFill/>
-          </a:ln>
-          <a:effectLst>
-            <a:outerShdw blurRad="25400" dist="12700" dir="5400000" algn="tl" rotWithShape="0">
-              <a:srgbClr val="000000">
-                <a:alpha val="10000"/>
-              </a:srgbClr>
-            </a:outerShdw>
-          </a:effectLst>
-        </p:spPr>
-        <p:txBody>
-          <a:bodyPr wrap="square" lIns="72000" tIns="54000" rIns="72000" bIns="54000" anchor="t"/>
-          <a:lstStyle/>
-          <a:p>
-            <a:endParaRPr lang="en-US"/>
-          </a:p>
-        </p:txBody>
-      </p:sp>
-      <p:sp>
-        <p:nvSpPr>
-          <p:cNvPr id="134" name="R134"/>
-          <p:cNvSpPr/>
-          <p:nvPr/>
-        </p:nvSpPr>
-        <p:spPr>
-          <a:xfrm>
-            <a:off x="10058400" y="1295400"/>
-            <a:ext cx="1905000" cy="50800"/>
+          <a:ln w="9525">
+            <a:solidFill>
+              <a:srgbClr val="7C3AED"/>
+            </a:solidFill>
+          </a:ln>
+        </p:spPr>
+        <p:txBody>
+          <a:bodyPr wrap="square" lIns="36000" tIns="18000" rIns="36000" bIns="18000" anchor="t"/>
+          <a:lstStyle/>
+          <a:p>
+            <a:pPr algn="ctr">
+              <a:buNone/>
+            </a:pPr>
+            <a:endParaRPr/>
+          </a:p>
+        </p:txBody>
+      </p:sp>
+      <p:sp>
+        <p:nvSpPr>
+          <p:cNvPr id="134" name="S134"/>
+          <p:cNvSpPr/>
+          <p:nvPr/>
+        </p:nvSpPr>
+        <p:spPr>
+          <a:xfrm>
+            <a:off x="4292600" y="3401060"/>
+            <a:ext cx="1803398" cy="58420"/>
           </a:xfrm>
           <a:prstGeom prst="rect">
             <a:avLst/>
@@ -22196,39 +22206,42 @@
           <a:solidFill>
             <a:srgbClr val="7C3AED"/>
           </a:solidFill>
-          <a:ln w="0">
-            <a:noFill/>
-          </a:ln>
-        </p:spPr>
-        <p:txBody>
-          <a:bodyPr/>
-          <a:lstStyle/>
-          <a:p>
-            <a:endParaRPr lang="en-US"/>
-          </a:p>
-        </p:txBody>
-      </p:sp>
-      <p:sp>
-        <p:nvSpPr>
-          <p:cNvPr id="135" name="T135"/>
-          <p:cNvSpPr/>
-          <p:nvPr/>
-        </p:nvSpPr>
-        <p:spPr>
-          <a:xfrm>
-            <a:off x="10185400" y="1473200"/>
-            <a:ext cx="1651000" cy="254000"/>
+          <a:ln>
+            <a:noFill/>
+          </a:ln>
+        </p:spPr>
+        <p:txBody>
+          <a:bodyPr wrap="square" lIns="36000" tIns="18000" rIns="36000" bIns="18000" anchor="ctr"/>
+          <a:lstStyle/>
+          <a:p>
+            <a:pPr algn="l">
+              <a:buNone/>
+            </a:pPr>
+            <a:endParaRPr/>
+          </a:p>
+        </p:txBody>
+      </p:sp>
+      <p:sp>
+        <p:nvSpPr>
+          <p:cNvPr id="135" name="S135"/>
+          <p:cNvSpPr/>
+          <p:nvPr/>
+        </p:nvSpPr>
+        <p:spPr>
+          <a:xfrm>
+            <a:off x="4292600" y="3581400"/>
+            <a:ext cx="1727200" cy="279400"/>
           </a:xfrm>
           <a:prstGeom prst="rect">
             <a:avLst/>
           </a:prstGeom>
           <a:noFill/>
-          <a:ln w="0">
-            <a:noFill/>
-          </a:ln>
-        </p:spPr>
-        <p:txBody>
-          <a:bodyPr wrap="square" lIns="0" tIns="0" rIns="0" bIns="0" anchor="t"/>
+          <a:ln>
+            <a:noFill/>
+          </a:ln>
+        </p:spPr>
+        <p:txBody>
+          <a:bodyPr wrap="square" lIns="36000" tIns="18000" rIns="36000" bIns="18000" anchor="ctr"/>
           <a:lstStyle/>
           <a:p>
             <a:pPr algn="ctr">
@@ -22248,25 +22261,25 @@
       </p:sp>
       <p:sp>
         <p:nvSpPr>
-          <p:cNvPr id="136" name="T136"/>
-          <p:cNvSpPr/>
-          <p:nvPr/>
-        </p:nvSpPr>
-        <p:spPr>
-          <a:xfrm>
-            <a:off x="10185400" y="1752600"/>
-            <a:ext cx="1651000" cy="228600"/>
+          <p:cNvPr id="136" name="S136"/>
+          <p:cNvSpPr/>
+          <p:nvPr/>
+        </p:nvSpPr>
+        <p:spPr>
+          <a:xfrm>
+            <a:off x="4292600" y="3860800"/>
+            <a:ext cx="1727200" cy="228600"/>
           </a:xfrm>
           <a:prstGeom prst="rect">
             <a:avLst/>
           </a:prstGeom>
           <a:noFill/>
-          <a:ln w="0">
-            <a:noFill/>
-          </a:ln>
-        </p:spPr>
-        <p:txBody>
-          <a:bodyPr wrap="square" lIns="0" tIns="0" rIns="0" bIns="0" anchor="t"/>
+          <a:ln>
+            <a:noFill/>
+          </a:ln>
+        </p:spPr>
+        <p:txBody>
+          <a:bodyPr wrap="square" lIns="36000" tIns="18000" rIns="36000" bIns="18000" anchor="ctr"/>
           <a:lstStyle/>
           <a:p>
             <a:pPr algn="ctr">
@@ -22292,96 +22305,1452 @@
         </p:nvCxnSpPr>
         <p:spPr>
           <a:xfrm>
-            <a:off x="10236200" y="2032000"/>
-            <a:ext cx="1549400" cy="0"/>
-          </a:xfrm>
-          <a:prstGeom prst="straightConnector1">
+            <a:off x="4394200" y="4140200"/>
+            <a:ext cx="1524000" cy="0"/>
+          </a:xfrm>
+          <a:prstGeom prst="line">
+            <a:avLst/>
+          </a:prstGeom>
+          <a:ln w="6350">
+            <a:solidFill>
+              <a:srgbClr val="E2E8F0"/>
+            </a:solidFill>
+          </a:ln>
+        </p:spPr>
+      </p:cxnSp>
+      <p:sp>
+        <p:nvSpPr>
+          <p:cNvPr id="138" name="S138"/>
+          <p:cNvSpPr/>
+          <p:nvPr/>
+        </p:nvSpPr>
+        <p:spPr>
+          <a:xfrm>
+            <a:off x="4292600" y="4216400"/>
+            <a:ext cx="1727200" cy="1663700"/>
+          </a:xfrm>
+          <a:prstGeom prst="rect">
+            <a:avLst/>
+          </a:prstGeom>
+          <a:noFill/>
+          <a:ln>
+            <a:noFill/>
+          </a:ln>
+        </p:spPr>
+        <p:txBody>
+          <a:bodyPr wrap="square" lIns="36000" tIns="18000" rIns="36000" bIns="18000" anchor="t"/>
+          <a:lstStyle/>
+          <a:p>
+            <a:pPr algn="ctr">
+              <a:buNone/>
+            </a:pPr>
+            <a:r>
+              <a:rPr lang="en-US" sz="1100" dirty="0">
+                <a:solidFill>
+                  <a:srgbClr val="475569"/>
+                </a:solidFill>
+                <a:latin typeface="Aptos"/>
+              </a:rPr>
+              <a:t>Strongest reasoning for complex architecture, long-running agentic work, and cross-cutting decisions.</a:t>
+            </a:r>
+          </a:p>
+        </p:txBody>
+      </p:sp>
+      <p:sp>
+        <p:nvSpPr>
+          <p:cNvPr id="141" name="S141"/>
+          <p:cNvSpPr/>
+          <p:nvPr/>
+        </p:nvSpPr>
+        <p:spPr>
+          <a:xfrm>
+            <a:off x="6553200" y="990600"/>
+            <a:ext cx="2540000" cy="203200"/>
+          </a:xfrm>
+          <a:prstGeom prst="rect">
+            <a:avLst/>
+          </a:prstGeom>
+          <a:noFill/>
+          <a:ln>
+            <a:noFill/>
+          </a:ln>
+        </p:spPr>
+        <p:txBody>
+          <a:bodyPr wrap="square" lIns="36000" tIns="18000" rIns="36000" bIns="18000" anchor="ctr"/>
+          <a:lstStyle/>
+          <a:p>
+            <a:pPr algn="l">
+              <a:buNone/>
+            </a:pPr>
+            <a:r>
+              <a:rPr lang="en-US" sz="1100" b="1" dirty="0">
+                <a:solidFill>
+                  <a:srgbClr val="64748B"/>
+                </a:solidFill>
+                <a:latin typeface="Aptos Display"/>
+              </a:rPr>
+              <a:t>TEAM STRUCTURE</a:t>
+            </a:r>
+          </a:p>
+        </p:txBody>
+      </p:sp>
+      <p:sp>
+        <p:nvSpPr>
+          <p:cNvPr id="142" name="S142"/>
+          <p:cNvSpPr/>
+          <p:nvPr/>
+        </p:nvSpPr>
+        <p:spPr>
+          <a:xfrm>
+            <a:off x="8077200" y="1219200"/>
+            <a:ext cx="2362200" cy="381000"/>
+          </a:xfrm>
+          <a:prstGeom prst="roundRect">
+            <a:avLst>
+              <a:gd name="adj" fmla="val 10000"/>
+            </a:avLst>
+          </a:prstGeom>
+          <a:solidFill>
+            <a:srgbClr val="1E3A5F"/>
+          </a:solidFill>
+          <a:ln>
+            <a:noFill/>
+          </a:ln>
+        </p:spPr>
+        <p:txBody>
+          <a:bodyPr wrap="square" lIns="36000" tIns="18000" rIns="36000" bIns="18000" anchor="ctr"/>
+          <a:lstStyle/>
+          <a:p>
+            <a:pPr algn="ctr">
+              <a:buNone/>
+            </a:pPr>
+            <a:r>
+              <a:rPr lang="en-US" sz="1100" b="1" dirty="0">
+                <a:solidFill>
+                  <a:srgbClr val="FFFFFF"/>
+                </a:solidFill>
+                <a:latin typeface="Aptos"/>
+              </a:rPr>
+              <a:t>Sr. Eng. Manager (Rahul)</a:t>
+            </a:r>
+          </a:p>
+        </p:txBody>
+      </p:sp>
+      <p:cxnSp>
+        <p:nvCxnSpPr>
+          <p:cNvPr id="143" name="L143"/>
+          <p:cNvCxnSpPr/>
+          <p:nvPr/>
+        </p:nvCxnSpPr>
+        <p:spPr>
+          <a:xfrm>
+            <a:off x="9258300" y="1600200"/>
+            <a:ext cx="0" cy="152400"/>
+          </a:xfrm>
+          <a:prstGeom prst="line">
             <a:avLst/>
           </a:prstGeom>
           <a:ln w="9525">
+            <a:solidFill>
+              <a:srgbClr val="94A3B8"/>
+            </a:solidFill>
+          </a:ln>
+        </p:spPr>
+      </p:cxnSp>
+      <p:cxnSp>
+        <p:nvCxnSpPr>
+          <p:cNvPr id="144" name="L144"/>
+          <p:cNvCxnSpPr/>
+          <p:nvPr/>
+        </p:nvCxnSpPr>
+        <p:spPr>
+          <a:xfrm>
+            <a:off x="7442200" y="1752600"/>
+            <a:ext cx="3632200" cy="0"/>
+          </a:xfrm>
+          <a:prstGeom prst="line">
+            <a:avLst/>
+          </a:prstGeom>
+          <a:ln w="9525">
+            <a:solidFill>
+              <a:srgbClr val="94A3B8"/>
+            </a:solidFill>
+          </a:ln>
+        </p:spPr>
+      </p:cxnSp>
+      <p:cxnSp>
+        <p:nvCxnSpPr>
+          <p:cNvPr id="145" name="L145"/>
+          <p:cNvCxnSpPr/>
+          <p:nvPr/>
+        </p:nvCxnSpPr>
+        <p:spPr>
+          <a:xfrm>
+            <a:off x="7442200" y="1752600"/>
+            <a:ext cx="0" cy="127000"/>
+          </a:xfrm>
+          <a:prstGeom prst="line">
+            <a:avLst/>
+          </a:prstGeom>
+          <a:ln w="9525">
+            <a:solidFill>
+              <a:srgbClr val="94A3B8"/>
+            </a:solidFill>
+          </a:ln>
+        </p:spPr>
+      </p:cxnSp>
+      <p:cxnSp>
+        <p:nvCxnSpPr>
+          <p:cNvPr id="146" name="L146"/>
+          <p:cNvCxnSpPr/>
+          <p:nvPr/>
+        </p:nvCxnSpPr>
+        <p:spPr>
+          <a:xfrm>
+            <a:off x="9258300" y="1752600"/>
+            <a:ext cx="0" cy="127000"/>
+          </a:xfrm>
+          <a:prstGeom prst="line">
+            <a:avLst/>
+          </a:prstGeom>
+          <a:ln w="9525">
+            <a:solidFill>
+              <a:srgbClr val="94A3B8"/>
+            </a:solidFill>
+          </a:ln>
+        </p:spPr>
+      </p:cxnSp>
+      <p:cxnSp>
+        <p:nvCxnSpPr>
+          <p:cNvPr id="147" name="L147"/>
+          <p:cNvCxnSpPr/>
+          <p:nvPr/>
+        </p:nvCxnSpPr>
+        <p:spPr>
+          <a:xfrm>
+            <a:off x="11074400" y="1752600"/>
+            <a:ext cx="0" cy="127000"/>
+          </a:xfrm>
+          <a:prstGeom prst="line">
+            <a:avLst/>
+          </a:prstGeom>
+          <a:ln w="9525">
+            <a:solidFill>
+              <a:srgbClr val="94A3B8"/>
+            </a:solidFill>
+          </a:ln>
+        </p:spPr>
+      </p:cxnSp>
+      <p:sp>
+        <p:nvSpPr>
+          <p:cNvPr id="148" name="S148"/>
+          <p:cNvSpPr/>
+          <p:nvPr/>
+        </p:nvSpPr>
+        <p:spPr>
+          <a:xfrm>
+            <a:off x="6654800" y="1879600"/>
+            <a:ext cx="1574800" cy="330200"/>
+          </a:xfrm>
+          <a:prstGeom prst="roundRect">
+            <a:avLst>
+              <a:gd name="adj" fmla="val 10000"/>
+            </a:avLst>
+          </a:prstGeom>
+          <a:solidFill>
+            <a:srgbClr val="1565C0"/>
+          </a:solidFill>
+          <a:ln>
+            <a:noFill/>
+          </a:ln>
+        </p:spPr>
+        <p:txBody>
+          <a:bodyPr wrap="square" lIns="36000" tIns="18000" rIns="36000" bIns="18000" anchor="ctr"/>
+          <a:lstStyle/>
+          <a:p>
+            <a:pPr algn="ctr">
+              <a:buNone/>
+            </a:pPr>
+            <a:r>
+              <a:rPr lang="en-US" sz="1000" b="1" dirty="0">
+                <a:solidFill>
+                  <a:srgbClr val="FFFFFF"/>
+                </a:solidFill>
+                <a:latin typeface="Aptos"/>
+              </a:rPr>
+              <a:t>Eng. Mgr A (Priya)</a:t>
+            </a:r>
+          </a:p>
+        </p:txBody>
+      </p:sp>
+      <p:sp>
+        <p:nvSpPr>
+          <p:cNvPr id="149" name="S149"/>
+          <p:cNvSpPr/>
+          <p:nvPr/>
+        </p:nvSpPr>
+        <p:spPr>
+          <a:xfrm>
+            <a:off x="8470900" y="1879600"/>
+            <a:ext cx="1574800" cy="330200"/>
+          </a:xfrm>
+          <a:prstGeom prst="roundRect">
+            <a:avLst>
+              <a:gd name="adj" fmla="val 10000"/>
+            </a:avLst>
+          </a:prstGeom>
+          <a:solidFill>
+            <a:srgbClr val="7C3AED"/>
+          </a:solidFill>
+          <a:ln>
+            <a:noFill/>
+          </a:ln>
+        </p:spPr>
+        <p:txBody>
+          <a:bodyPr wrap="square" lIns="36000" tIns="18000" rIns="36000" bIns="18000" anchor="ctr"/>
+          <a:lstStyle/>
+          <a:p>
+            <a:pPr algn="ctr">
+              <a:buNone/>
+            </a:pPr>
+            <a:r>
+              <a:rPr lang="en-US" sz="1000" b="1" dirty="0">
+                <a:solidFill>
+                  <a:srgbClr val="FFFFFF"/>
+                </a:solidFill>
+                <a:latin typeface="Aptos"/>
+              </a:rPr>
+              <a:t>Architect (Amit)</a:t>
+            </a:r>
+          </a:p>
+        </p:txBody>
+      </p:sp>
+      <p:sp>
+        <p:nvSpPr>
+          <p:cNvPr id="150" name="S150"/>
+          <p:cNvSpPr/>
+          <p:nvPr/>
+        </p:nvSpPr>
+        <p:spPr>
+          <a:xfrm>
+            <a:off x="10287000" y="1879600"/>
+            <a:ext cx="1574800" cy="330200"/>
+          </a:xfrm>
+          <a:prstGeom prst="roundRect">
+            <a:avLst>
+              <a:gd name="adj" fmla="val 10000"/>
+            </a:avLst>
+          </a:prstGeom>
+          <a:solidFill>
+            <a:srgbClr val="059669"/>
+          </a:solidFill>
+          <a:ln>
+            <a:noFill/>
+          </a:ln>
+        </p:spPr>
+        <p:txBody>
+          <a:bodyPr wrap="square" lIns="36000" tIns="18000" rIns="36000" bIns="18000" anchor="ctr"/>
+          <a:lstStyle/>
+          <a:p>
+            <a:pPr algn="ctr">
+              <a:buNone/>
+            </a:pPr>
+            <a:r>
+              <a:rPr lang="en-US" sz="1000" b="1" dirty="0">
+                <a:solidFill>
+                  <a:srgbClr val="FFFFFF"/>
+                </a:solidFill>
+                <a:latin typeface="Aptos"/>
+              </a:rPr>
+              <a:t>Eng. Mgr B (Sara)</a:t>
+            </a:r>
+          </a:p>
+        </p:txBody>
+      </p:sp>
+      <p:cxnSp>
+        <p:nvCxnSpPr>
+          <p:cNvPr id="151" name="L151"/>
+          <p:cNvCxnSpPr/>
+          <p:nvPr/>
+        </p:nvCxnSpPr>
+        <p:spPr>
+          <a:xfrm>
+            <a:off x="7442200" y="2209800"/>
+            <a:ext cx="0" cy="114300"/>
+          </a:xfrm>
+          <a:prstGeom prst="line">
+            <a:avLst/>
+          </a:prstGeom>
+          <a:ln w="6350">
+            <a:solidFill>
+              <a:srgbClr val="94A3B8"/>
+            </a:solidFill>
+          </a:ln>
+        </p:spPr>
+      </p:cxnSp>
+      <p:sp>
+        <p:nvSpPr>
+          <p:cNvPr id="152" name="S152"/>
+          <p:cNvSpPr/>
+          <p:nvPr/>
+        </p:nvSpPr>
+        <p:spPr>
+          <a:xfrm>
+            <a:off x="6654800" y="2336800"/>
+            <a:ext cx="1574800" cy="228600"/>
+          </a:xfrm>
+          <a:prstGeom prst="roundRect">
+            <a:avLst>
+              <a:gd name="adj" fmla="val 10000"/>
+            </a:avLst>
+          </a:prstGeom>
+          <a:solidFill>
+            <a:srgbClr val="DBEAFE"/>
+          </a:solidFill>
+          <a:ln w="6350">
+            <a:solidFill>
+              <a:srgbClr val="93C5FD"/>
+            </a:solidFill>
+          </a:ln>
+        </p:spPr>
+        <p:txBody>
+          <a:bodyPr wrap="square" lIns="36000" tIns="18000" rIns="36000" bIns="18000" anchor="ctr"/>
+          <a:lstStyle/>
+          <a:p>
+            <a:pPr algn="ctr">
+              <a:buNone/>
+            </a:pPr>
+            <a:r>
+              <a:rPr lang="en-US" sz="900" dirty="0">
+                <a:solidFill>
+                  <a:srgbClr val="1565C0"/>
+                </a:solidFill>
+                <a:latin typeface="Aptos"/>
+              </a:rPr>
+              <a:t>5 Engineers</a:t>
+            </a:r>
+          </a:p>
+        </p:txBody>
+      </p:sp>
+      <p:cxnSp>
+        <p:nvCxnSpPr>
+          <p:cNvPr id="153" name="L153"/>
+          <p:cNvCxnSpPr/>
+          <p:nvPr/>
+        </p:nvCxnSpPr>
+        <p:spPr>
+          <a:xfrm>
+            <a:off x="11074400" y="2209800"/>
+            <a:ext cx="0" cy="114300"/>
+          </a:xfrm>
+          <a:prstGeom prst="line">
+            <a:avLst/>
+          </a:prstGeom>
+          <a:ln w="6350">
+            <a:solidFill>
+              <a:srgbClr val="94A3B8"/>
+            </a:solidFill>
+          </a:ln>
+        </p:spPr>
+      </p:cxnSp>
+      <p:sp>
+        <p:nvSpPr>
+          <p:cNvPr id="154" name="S154"/>
+          <p:cNvSpPr/>
+          <p:nvPr/>
+        </p:nvSpPr>
+        <p:spPr>
+          <a:xfrm>
+            <a:off x="10287000" y="2336800"/>
+            <a:ext cx="1574800" cy="228600"/>
+          </a:xfrm>
+          <a:prstGeom prst="roundRect">
+            <a:avLst>
+              <a:gd name="adj" fmla="val 10000"/>
+            </a:avLst>
+          </a:prstGeom>
+          <a:solidFill>
+            <a:srgbClr val="D1FAE5"/>
+          </a:solidFill>
+          <a:ln w="6350">
+            <a:solidFill>
+              <a:srgbClr val="6EE7B7"/>
+            </a:solidFill>
+          </a:ln>
+        </p:spPr>
+        <p:txBody>
+          <a:bodyPr wrap="square" lIns="36000" tIns="18000" rIns="36000" bIns="18000" anchor="ctr"/>
+          <a:lstStyle/>
+          <a:p>
+            <a:pPr algn="ctr">
+              <a:buNone/>
+            </a:pPr>
+            <a:r>
+              <a:rPr lang="en-US" sz="900" dirty="0">
+                <a:solidFill>
+                  <a:srgbClr val="059669"/>
+                </a:solidFill>
+                <a:latin typeface="Aptos"/>
+              </a:rPr>
+              <a:t>5 Engineers</a:t>
+            </a:r>
+          </a:p>
+        </p:txBody>
+      </p:sp>
+      <p:sp>
+        <p:nvSpPr>
+          <p:cNvPr id="155" name="S155"/>
+          <p:cNvSpPr/>
+          <p:nvPr/>
+        </p:nvSpPr>
+        <p:spPr>
+          <a:xfrm>
+            <a:off x="6553200" y="2717800"/>
+            <a:ext cx="2540000" cy="203200"/>
+          </a:xfrm>
+          <a:prstGeom prst="rect">
+            <a:avLst/>
+          </a:prstGeom>
+          <a:noFill/>
+          <a:ln>
+            <a:noFill/>
+          </a:ln>
+        </p:spPr>
+        <p:txBody>
+          <a:bodyPr wrap="square" lIns="36000" tIns="18000" rIns="36000" bIns="18000" anchor="ctr"/>
+          <a:lstStyle/>
+          <a:p>
+            <a:pPr algn="l">
+              <a:buNone/>
+            </a:pPr>
+            <a:r>
+              <a:rPr lang="en-US" sz="1100" b="1" dirty="0">
+                <a:solidFill>
+                  <a:srgbClr val="64748B"/>
+                </a:solidFill>
+                <a:latin typeface="Aptos Display"/>
+              </a:rPr>
+              <a:t>INCOMING TASKS</a:t>
+            </a:r>
+          </a:p>
+        </p:txBody>
+      </p:sp>
+      <p:sp>
+        <p:nvSpPr>
+          <p:cNvPr id="156" name="S156"/>
+          <p:cNvSpPr/>
+          <p:nvPr/>
+        </p:nvSpPr>
+        <p:spPr>
+          <a:xfrm>
+            <a:off x="6553200" y="2946400"/>
+            <a:ext cx="2540000" cy="444500"/>
+          </a:xfrm>
+          <a:prstGeom prst="roundRect">
+            <a:avLst>
+              <a:gd name="adj" fmla="val 12000"/>
+            </a:avLst>
+          </a:prstGeom>
+          <a:solidFill>
+            <a:srgbClr val="FEF3C7"/>
+          </a:solidFill>
+          <a:ln w="9525">
+            <a:solidFill>
+              <a:srgbClr val="F59E0B"/>
+            </a:solidFill>
+          </a:ln>
+        </p:spPr>
+        <p:txBody>
+          <a:bodyPr wrap="square" lIns="36000" tIns="18000" rIns="36000" bIns="18000" anchor="ctr"/>
+          <a:lstStyle/>
+          <a:p>
+            <a:pPr algn="l">
+              <a:buNone/>
+            </a:pPr>
+            <a:r>
+              <a:rPr lang="en-US" sz="1000" b="1" dirty="0">
+                <a:solidFill>
+                  <a:srgbClr val="92400E"/>
+                </a:solidFill>
+                <a:latin typeface="Aptos"/>
+              </a:rPr>
+              <a:t>📦  Release v2.3 to Production</a:t>
+            </a:r>
+          </a:p>
+          <a:p>
+            <a:pPr algn="l">
+              <a:buNone/>
+            </a:pPr>
+            <a:r>
+              <a:rPr lang="en-US" sz="800" dirty="0">
+                <a:solidFill>
+                  <a:srgbClr val="A16207"/>
+                </a:solidFill>
+                <a:latin typeface="Aptos"/>
+              </a:rPr>
+              <a:t>Cross-team coordination needed</a:t>
+            </a:r>
+          </a:p>
+        </p:txBody>
+      </p:sp>
+      <p:sp>
+        <p:nvSpPr>
+          <p:cNvPr id="157" name="S157"/>
+          <p:cNvSpPr/>
+          <p:nvPr/>
+        </p:nvSpPr>
+        <p:spPr>
+          <a:xfrm>
+            <a:off x="6553200" y="3429000"/>
+            <a:ext cx="2540000" cy="444500"/>
+          </a:xfrm>
+          <a:prstGeom prst="roundRect">
+            <a:avLst>
+              <a:gd name="adj" fmla="val 12000"/>
+            </a:avLst>
+          </a:prstGeom>
+          <a:solidFill>
+            <a:srgbClr val="EDE9FE"/>
+          </a:solidFill>
+          <a:ln w="9525">
+            <a:solidFill>
+              <a:srgbClr val="8B5CF6"/>
+            </a:solidFill>
+          </a:ln>
+        </p:spPr>
+        <p:txBody>
+          <a:bodyPr wrap="square" lIns="36000" tIns="18000" rIns="36000" bIns="18000" anchor="ctr"/>
+          <a:lstStyle/>
+          <a:p>
+            <a:pPr algn="l">
+              <a:buNone/>
+            </a:pPr>
+            <a:r>
+              <a:rPr lang="en-US" sz="1000" b="1" dirty="0">
+                <a:solidFill>
+                  <a:srgbClr val="5B21B6"/>
+                </a:solidFill>
+                <a:latin typeface="Aptos"/>
+              </a:rPr>
+              <a:t>💡  Design Payment Gateway</a:t>
+            </a:r>
+          </a:p>
+          <a:p>
+            <a:pPr algn="l">
+              <a:buNone/>
+            </a:pPr>
+            <a:r>
+              <a:rPr lang="en-US" sz="800" dirty="0">
+                <a:solidFill>
+                  <a:srgbClr val="6D28D9"/>
+                </a:solidFill>
+                <a:latin typeface="Aptos"/>
+              </a:rPr>
+              <a:t>Architecture &amp; trade-off analysis</a:t>
+            </a:r>
+          </a:p>
+        </p:txBody>
+      </p:sp>
+      <p:sp>
+        <p:nvSpPr>
+          <p:cNvPr id="158" name="S158"/>
+          <p:cNvSpPr/>
+          <p:nvPr/>
+        </p:nvSpPr>
+        <p:spPr>
+          <a:xfrm>
+            <a:off x="6553200" y="3911600"/>
+            <a:ext cx="2540000" cy="444500"/>
+          </a:xfrm>
+          <a:prstGeom prst="roundRect">
+            <a:avLst>
+              <a:gd name="adj" fmla="val 12000"/>
+            </a:avLst>
+          </a:prstGeom>
+          <a:solidFill>
+            <a:srgbClr val="DBEAFE"/>
+          </a:solidFill>
+          <a:ln w="9525">
+            <a:solidFill>
+              <a:srgbClr val="3B82F6"/>
+            </a:solidFill>
+          </a:ln>
+        </p:spPr>
+        <p:txBody>
+          <a:bodyPr wrap="square" lIns="36000" tIns="18000" rIns="36000" bIns="18000" anchor="ctr"/>
+          <a:lstStyle/>
+          <a:p>
+            <a:pPr algn="l">
+              <a:buNone/>
+            </a:pPr>
+            <a:r>
+              <a:rPr lang="en-US" sz="1000" b="1" dirty="0">
+                <a:solidFill>
+                  <a:srgbClr val="1E40AF"/>
+                </a:solidFill>
+                <a:latin typeface="Aptos"/>
+              </a:rPr>
+              <a:t>⚙️  Migrate to Kubernetes?</a:t>
+            </a:r>
+          </a:p>
+          <a:p>
+            <a:pPr algn="l">
+              <a:buNone/>
+            </a:pPr>
+            <a:r>
+              <a:rPr lang="en-US" sz="800" dirty="0">
+                <a:solidFill>
+                  <a:srgbClr val="1D4ED8"/>
+                </a:solidFill>
+                <a:latin typeface="Aptos"/>
+              </a:rPr>
+              <a:t>Evaluate effort, risk, timeline</a:t>
+            </a:r>
+          </a:p>
+        </p:txBody>
+      </p:sp>
+      <p:sp>
+        <p:nvSpPr>
+          <p:cNvPr id="159" name="S159"/>
+          <p:cNvSpPr/>
+          <p:nvPr/>
+        </p:nvSpPr>
+        <p:spPr>
+          <a:xfrm>
+            <a:off x="6553200" y="4394200"/>
+            <a:ext cx="2540000" cy="444500"/>
+          </a:xfrm>
+          <a:prstGeom prst="roundRect">
+            <a:avLst>
+              <a:gd name="adj" fmla="val 12000"/>
+            </a:avLst>
+          </a:prstGeom>
+          <a:solidFill>
+            <a:srgbClr val="F0FDF4"/>
+          </a:solidFill>
+          <a:ln w="9525">
+            <a:solidFill>
+              <a:srgbClr val="22C55E"/>
+            </a:solidFill>
+          </a:ln>
+        </p:spPr>
+        <p:txBody>
+          <a:bodyPr wrap="square" lIns="36000" tIns="18000" rIns="36000" bIns="18000" anchor="ctr"/>
+          <a:lstStyle/>
+          <a:p>
+            <a:pPr algn="l">
+              <a:buNone/>
+            </a:pPr>
+            <a:r>
+              <a:rPr lang="en-US" sz="1000" b="1" dirty="0">
+                <a:solidFill>
+                  <a:srgbClr val="166534"/>
+                </a:solidFill>
+                <a:latin typeface="Aptos"/>
+              </a:rPr>
+              <a:t>📋  JIRA-1234: Fix login bug</a:t>
+            </a:r>
+          </a:p>
+          <a:p>
+            <a:pPr algn="l">
+              <a:buNone/>
+            </a:pPr>
+            <a:r>
+              <a:rPr lang="en-US" sz="800" dirty="0">
+                <a:solidFill>
+                  <a:srgbClr val="15803D"/>
+                </a:solidFill>
+                <a:latin typeface="Aptos"/>
+              </a:rPr>
+              <a:t>Standard story / bug fix</a:t>
+            </a:r>
+          </a:p>
+        </p:txBody>
+      </p:sp>
+      <p:sp>
+        <p:nvSpPr>
+          <p:cNvPr id="160" name="S160"/>
+          <p:cNvSpPr/>
+          <p:nvPr/>
+        </p:nvSpPr>
+        <p:spPr>
+          <a:xfrm>
+            <a:off x="9271000" y="2717800"/>
+            <a:ext cx="2794000" cy="203200"/>
+          </a:xfrm>
+          <a:prstGeom prst="rect">
+            <a:avLst/>
+          </a:prstGeom>
+          <a:noFill/>
+          <a:ln>
+            <a:noFill/>
+          </a:ln>
+        </p:spPr>
+        <p:txBody>
+          <a:bodyPr wrap="square" lIns="36000" tIns="18000" rIns="36000" bIns="18000" anchor="ctr"/>
+          <a:lstStyle/>
+          <a:p>
+            <a:pPr algn="l">
+              <a:buNone/>
+            </a:pPr>
+            <a:r>
+              <a:rPr lang="en-US" sz="1100" b="1" dirty="0">
+                <a:solidFill>
+                  <a:srgbClr val="1E293B"/>
+                </a:solidFill>
+                <a:latin typeface="Aptos Display"/>
+              </a:rPr>
+              <a:t>SR. MANAGER DECIDES:</a:t>
+            </a:r>
+          </a:p>
+        </p:txBody>
+      </p:sp>
+      <p:cxnSp>
+        <p:nvCxnSpPr>
+          <p:cNvPr id="161" name="L161"/>
+          <p:cNvCxnSpPr/>
+          <p:nvPr/>
+        </p:nvCxnSpPr>
+        <p:spPr>
+          <a:xfrm>
+            <a:off x="9398000" y="2946400"/>
+            <a:ext cx="0" cy="2006600"/>
+          </a:xfrm>
+          <a:prstGeom prst="line">
+            <a:avLst/>
+          </a:prstGeom>
+          <a:ln w="6350">
+            <a:solidFill>
+              <a:srgbClr val="CBD5E1"/>
+            </a:solidFill>
+            <a:prstDash val="dash"/>
+          </a:ln>
+        </p:spPr>
+      </p:cxnSp>
+      <p:sp>
+        <p:nvSpPr>
+          <p:cNvPr id="162" name="S162"/>
+          <p:cNvSpPr/>
+          <p:nvPr/>
+        </p:nvSpPr>
+        <p:spPr>
+          <a:xfrm>
+            <a:off x="9626599" y="2946400"/>
+            <a:ext cx="2006593" cy="444500"/>
+          </a:xfrm>
+          <a:prstGeom prst="rect">
+            <a:avLst/>
+          </a:prstGeom>
+          <a:noFill/>
+          <a:ln>
+            <a:noFill/>
+          </a:ln>
+        </p:spPr>
+        <p:txBody>
+          <a:bodyPr wrap="square" lIns="36000" tIns="18000" rIns="36000" bIns="18000" anchor="ctr"/>
+          <a:lstStyle/>
+          <a:p>
+            <a:pPr algn="l">
+              <a:buNone/>
+            </a:pPr>
+            <a:r>
+              <a:rPr lang="en-US" sz="1050" b="1" dirty="0">
+                <a:solidFill>
+                  <a:srgbClr val="92400E"/>
+                </a:solidFill>
+                <a:latin typeface="Aptos"/>
+              </a:rPr>
+              <a:t>▶ Delivery task?</a:t>
+            </a:r>
+          </a:p>
+          <a:p>
+            <a:pPr algn="l">
+              <a:buNone/>
+            </a:pPr>
+            <a:r>
+              <a:rPr lang="en-US" sz="900" dirty="0">
+                <a:solidFill>
+                  <a:srgbClr val="64748B"/>
+                </a:solidFill>
+                <a:latin typeface="Aptos"/>
+              </a:rPr>
+              <a:t>  Manager leads the release</a:t>
+            </a:r>
+          </a:p>
+        </p:txBody>
+      </p:sp>
+      <p:sp>
+        <p:nvSpPr>
+          <p:cNvPr id="163" name="S163"/>
+          <p:cNvSpPr/>
+          <p:nvPr/>
+        </p:nvSpPr>
+        <p:spPr>
+          <a:xfrm>
+            <a:off x="9626600" y="3429000"/>
+            <a:ext cx="2006598" cy="444500"/>
+          </a:xfrm>
+          <a:prstGeom prst="rect">
+            <a:avLst/>
+          </a:prstGeom>
+          <a:noFill/>
+          <a:ln>
+            <a:noFill/>
+          </a:ln>
+        </p:spPr>
+        <p:txBody>
+          <a:bodyPr wrap="square" lIns="36000" tIns="18000" rIns="36000" bIns="18000" anchor="ctr"/>
+          <a:lstStyle/>
+          <a:p>
+            <a:pPr algn="l">
+              <a:buNone/>
+            </a:pPr>
+            <a:r>
+              <a:rPr lang="en-US" sz="1050" b="1" dirty="0">
+                <a:solidFill>
+                  <a:srgbClr val="7C3AED"/>
+                </a:solidFill>
+                <a:latin typeface="Aptos"/>
+              </a:rPr>
+              <a:t>▶ Architecture / Design?</a:t>
+            </a:r>
+          </a:p>
+          <a:p>
+            <a:pPr algn="l">
+              <a:buNone/>
+            </a:pPr>
+            <a:r>
+              <a:rPr lang="en-US" sz="900" dirty="0">
+                <a:solidFill>
+                  <a:srgbClr val="64748B"/>
+                </a:solidFill>
+                <a:latin typeface="Aptos"/>
+              </a:rPr>
+              <a:t>  Route to the Architect</a:t>
+            </a:r>
+          </a:p>
+        </p:txBody>
+      </p:sp>
+      <p:sp>
+        <p:nvSpPr>
+          <p:cNvPr id="164" name="S164"/>
+          <p:cNvSpPr/>
+          <p:nvPr/>
+        </p:nvSpPr>
+        <p:spPr>
+          <a:xfrm>
+            <a:off x="9626600" y="3911600"/>
+            <a:ext cx="2006587" cy="444500"/>
+          </a:xfrm>
+          <a:prstGeom prst="rect">
+            <a:avLst/>
+          </a:prstGeom>
+          <a:noFill/>
+          <a:ln>
+            <a:noFill/>
+          </a:ln>
+        </p:spPr>
+        <p:txBody>
+          <a:bodyPr wrap="square" lIns="36000" tIns="18000" rIns="36000" bIns="18000" anchor="ctr"/>
+          <a:lstStyle/>
+          <a:p>
+            <a:pPr algn="l">
+              <a:buNone/>
+            </a:pPr>
+            <a:r>
+              <a:rPr lang="en-US" sz="1050" b="1" dirty="0">
+                <a:solidFill>
+                  <a:srgbClr val="1565C0"/>
+                </a:solidFill>
+                <a:latin typeface="Aptos"/>
+              </a:rPr>
+              <a:t>▶ Tech stack decision?</a:t>
+            </a:r>
+          </a:p>
+          <a:p>
+            <a:pPr algn="l">
+              <a:buNone/>
+            </a:pPr>
+            <a:r>
+              <a:rPr lang="en-US" sz="900" dirty="0">
+                <a:solidFill>
+                  <a:srgbClr val="64748B"/>
+                </a:solidFill>
+                <a:latin typeface="Aptos"/>
+              </a:rPr>
+              <a:t>  SM decides + Architect input</a:t>
+            </a:r>
+          </a:p>
+        </p:txBody>
+      </p:sp>
+      <p:sp>
+        <p:nvSpPr>
+          <p:cNvPr id="165" name="S165"/>
+          <p:cNvSpPr/>
+          <p:nvPr/>
+        </p:nvSpPr>
+        <p:spPr>
+          <a:xfrm>
+            <a:off x="9626599" y="4394200"/>
+            <a:ext cx="2006569" cy="444500"/>
+          </a:xfrm>
+          <a:prstGeom prst="rect">
+            <a:avLst/>
+          </a:prstGeom>
+          <a:noFill/>
+          <a:ln>
+            <a:noFill/>
+          </a:ln>
+        </p:spPr>
+        <p:txBody>
+          <a:bodyPr wrap="square" lIns="36000" tIns="18000" rIns="36000" bIns="18000" anchor="ctr"/>
+          <a:lstStyle/>
+          <a:p>
+            <a:pPr algn="l">
+              <a:buNone/>
+            </a:pPr>
+            <a:r>
+              <a:rPr lang="en-US" sz="1050" b="1" dirty="0">
+                <a:solidFill>
+                  <a:srgbClr val="059669"/>
+                </a:solidFill>
+                <a:latin typeface="Aptos"/>
+              </a:rPr>
+              <a:t>▶ Story / Bug?</a:t>
+            </a:r>
+          </a:p>
+          <a:p>
+            <a:pPr algn="l">
+              <a:buNone/>
+            </a:pPr>
+            <a:r>
+              <a:rPr lang="en-US" sz="900" dirty="0">
+                <a:solidFill>
+                  <a:srgbClr val="64748B"/>
+                </a:solidFill>
+                <a:latin typeface="Aptos"/>
+              </a:rPr>
+              <a:t>  Managers delegate to Engineers</a:t>
+            </a:r>
+          </a:p>
+        </p:txBody>
+      </p:sp>
+      <p:cxnSp>
+        <p:nvCxnSpPr>
+          <p:cNvPr id="166" name="L166"/>
+          <p:cNvCxnSpPr/>
+          <p:nvPr/>
+        </p:nvCxnSpPr>
+        <p:spPr>
+          <a:xfrm>
+            <a:off x="9093200" y="3111500"/>
+            <a:ext cx="457200" cy="0"/>
+          </a:xfrm>
+          <a:prstGeom prst="line">
+            <a:avLst/>
+          </a:prstGeom>
+          <a:ln w="6350">
+            <a:solidFill>
+              <a:srgbClr val="CBD5E1"/>
+            </a:solidFill>
+          </a:ln>
+        </p:spPr>
+      </p:cxnSp>
+      <p:sp>
+        <p:nvSpPr>
+          <p:cNvPr id="167" name="S167"/>
+          <p:cNvSpPr/>
+          <p:nvPr/>
+        </p:nvSpPr>
+        <p:spPr>
+          <a:xfrm rot="5400000">
+            <a:off x="9499600" y="3073400"/>
+            <a:ext cx="76200" cy="76200"/>
+          </a:xfrm>
+          <a:prstGeom prst="triangle">
+            <a:avLst/>
+          </a:prstGeom>
+          <a:solidFill>
+            <a:srgbClr val="CBD5E1"/>
+          </a:solidFill>
+          <a:ln>
+            <a:noFill/>
+          </a:ln>
+        </p:spPr>
+        <p:txBody>
+          <a:bodyPr wrap="square" lIns="36000" tIns="18000" rIns="36000" bIns="18000" anchor="ctr"/>
+          <a:lstStyle/>
+          <a:p>
+            <a:pPr algn="ctr">
+              <a:buNone/>
+            </a:pPr>
+            <a:endParaRPr/>
+          </a:p>
+        </p:txBody>
+      </p:sp>
+      <p:cxnSp>
+        <p:nvCxnSpPr>
+          <p:cNvPr id="168" name="L168"/>
+          <p:cNvCxnSpPr/>
+          <p:nvPr/>
+        </p:nvCxnSpPr>
+        <p:spPr>
+          <a:xfrm>
+            <a:off x="9093200" y="3594100"/>
+            <a:ext cx="457200" cy="0"/>
+          </a:xfrm>
+          <a:prstGeom prst="line">
+            <a:avLst/>
+          </a:prstGeom>
+          <a:ln w="6350">
+            <a:solidFill>
+              <a:srgbClr val="CBD5E1"/>
+            </a:solidFill>
+          </a:ln>
+        </p:spPr>
+      </p:cxnSp>
+      <p:sp>
+        <p:nvSpPr>
+          <p:cNvPr id="169" name="S169"/>
+          <p:cNvSpPr/>
+          <p:nvPr/>
+        </p:nvSpPr>
+        <p:spPr>
+          <a:xfrm rot="5400000">
+            <a:off x="9499600" y="3566160"/>
+            <a:ext cx="76200" cy="76200"/>
+          </a:xfrm>
+          <a:prstGeom prst="triangle">
+            <a:avLst/>
+          </a:prstGeom>
+          <a:solidFill>
+            <a:srgbClr val="CBD5E1"/>
+          </a:solidFill>
+          <a:ln>
+            <a:noFill/>
+          </a:ln>
+        </p:spPr>
+        <p:txBody>
+          <a:bodyPr wrap="square" lIns="36000" tIns="18000" rIns="36000" bIns="18000" anchor="ctr"/>
+          <a:lstStyle/>
+          <a:p>
+            <a:pPr algn="ctr">
+              <a:buNone/>
+            </a:pPr>
+            <a:endParaRPr/>
+          </a:p>
+        </p:txBody>
+      </p:sp>
+      <p:cxnSp>
+        <p:nvCxnSpPr>
+          <p:cNvPr id="170" name="L170"/>
+          <p:cNvCxnSpPr/>
+          <p:nvPr/>
+        </p:nvCxnSpPr>
+        <p:spPr>
+          <a:xfrm>
+            <a:off x="9093200" y="4076700"/>
+            <a:ext cx="457200" cy="0"/>
+          </a:xfrm>
+          <a:prstGeom prst="line">
+            <a:avLst/>
+          </a:prstGeom>
+          <a:ln w="6350">
+            <a:solidFill>
+              <a:srgbClr val="CBD5E1"/>
+            </a:solidFill>
+          </a:ln>
+        </p:spPr>
+      </p:cxnSp>
+      <p:sp>
+        <p:nvSpPr>
+          <p:cNvPr id="171" name="S171"/>
+          <p:cNvSpPr/>
+          <p:nvPr/>
+        </p:nvSpPr>
+        <p:spPr>
+          <a:xfrm rot="19701525">
+            <a:off x="9499600" y="4028440"/>
+            <a:ext cx="76200" cy="76200"/>
+          </a:xfrm>
+          <a:prstGeom prst="triangle">
+            <a:avLst/>
+          </a:prstGeom>
+          <a:solidFill>
+            <a:srgbClr val="CBD5E1"/>
+          </a:solidFill>
+          <a:ln>
+            <a:noFill/>
+          </a:ln>
+        </p:spPr>
+        <p:txBody>
+          <a:bodyPr wrap="square" lIns="36000" tIns="18000" rIns="36000" bIns="18000" anchor="ctr"/>
+          <a:lstStyle/>
+          <a:p>
+            <a:pPr algn="ctr">
+              <a:buNone/>
+            </a:pPr>
+            <a:endParaRPr/>
+          </a:p>
+        </p:txBody>
+      </p:sp>
+      <p:cxnSp>
+        <p:nvCxnSpPr>
+          <p:cNvPr id="172" name="L172"/>
+          <p:cNvCxnSpPr/>
+          <p:nvPr/>
+        </p:nvCxnSpPr>
+        <p:spPr>
+          <a:xfrm>
+            <a:off x="9093200" y="4559300"/>
+            <a:ext cx="457200" cy="0"/>
+          </a:xfrm>
+          <a:prstGeom prst="line">
+            <a:avLst/>
+          </a:prstGeom>
+          <a:ln w="6350">
+            <a:solidFill>
+              <a:srgbClr val="CBD5E1"/>
+            </a:solidFill>
+          </a:ln>
+        </p:spPr>
+      </p:cxnSp>
+      <p:sp>
+        <p:nvSpPr>
+          <p:cNvPr id="173" name="S173"/>
+          <p:cNvSpPr/>
+          <p:nvPr/>
+        </p:nvSpPr>
+        <p:spPr>
+          <a:xfrm rot="5400000">
+            <a:off x="9499600" y="4531360"/>
+            <a:ext cx="76200" cy="76200"/>
+          </a:xfrm>
+          <a:prstGeom prst="triangle">
+            <a:avLst/>
+          </a:prstGeom>
+          <a:solidFill>
+            <a:srgbClr val="CBD5E1"/>
+          </a:solidFill>
+          <a:ln>
+            <a:noFill/>
+          </a:ln>
+        </p:spPr>
+        <p:txBody>
+          <a:bodyPr wrap="square" lIns="36000" tIns="18000" rIns="36000" bIns="18000" anchor="ctr"/>
+          <a:lstStyle/>
+          <a:p>
+            <a:pPr algn="ctr">
+              <a:buNone/>
+            </a:pPr>
+            <a:endParaRPr/>
+          </a:p>
+        </p:txBody>
+      </p:sp>
+      <p:sp>
+        <p:nvSpPr>
+          <p:cNvPr id="174" name="S174"/>
+          <p:cNvSpPr/>
+          <p:nvPr/>
+        </p:nvSpPr>
+        <p:spPr>
+          <a:xfrm>
+            <a:off x="6553200" y="5003800"/>
+            <a:ext cx="5461000" cy="177800"/>
+          </a:xfrm>
+          <a:prstGeom prst="rect">
+            <a:avLst/>
+          </a:prstGeom>
+          <a:noFill/>
+          <a:ln>
+            <a:noFill/>
+          </a:ln>
+        </p:spPr>
+        <p:txBody>
+          <a:bodyPr wrap="square" lIns="36000" tIns="18000" rIns="36000" bIns="18000" anchor="ctr"/>
+          <a:lstStyle/>
+          <a:p>
+            <a:pPr algn="l">
+              <a:buNone/>
+            </a:pPr>
+            <a:r>
+              <a:rPr lang="en-US" sz="1000" b="1" dirty="0">
+                <a:solidFill>
+                  <a:srgbClr val="94A3B8"/>
+                </a:solidFill>
+                <a:latin typeface="Aptos Display"/>
+              </a:rPr>
+              <a:t>ROLE → MODEL MAPPING</a:t>
+            </a:r>
+          </a:p>
+        </p:txBody>
+      </p:sp>
+      <p:sp>
+        <p:nvSpPr>
+          <p:cNvPr id="175" name="S175"/>
+          <p:cNvSpPr/>
+          <p:nvPr/>
+        </p:nvSpPr>
+        <p:spPr>
+          <a:xfrm>
+            <a:off x="6553200" y="5207000"/>
+            <a:ext cx="5461000" cy="279400"/>
+          </a:xfrm>
+          <a:prstGeom prst="roundRect">
+            <a:avLst>
+              <a:gd name="adj" fmla="val 10000"/>
+            </a:avLst>
+          </a:prstGeom>
+          <a:solidFill>
+            <a:srgbClr val="EFF6FF"/>
+          </a:solidFill>
+          <a:ln w="6350">
+            <a:solidFill>
+              <a:srgbClr val="1565C0"/>
+            </a:solidFill>
+          </a:ln>
+        </p:spPr>
+        <p:txBody>
+          <a:bodyPr wrap="square" lIns="36000" tIns="18000" rIns="36000" bIns="18000" anchor="ctr"/>
+          <a:lstStyle/>
+          <a:p>
+            <a:pPr algn="l">
+              <a:buNone/>
+            </a:pPr>
+            <a:r>
+              <a:rPr lang="en-US" sz="900" dirty="0">
+                <a:solidFill>
+                  <a:srgbClr val="1565C0"/>
+                </a:solidFill>
+                <a:latin typeface="Aptos"/>
+              </a:rPr>
+              <a:t>Eng. Managers  =  Sonnet 4.6  (Default, everyday coding)</a:t>
+            </a:r>
+          </a:p>
+        </p:txBody>
+      </p:sp>
+      <p:sp>
+        <p:nvSpPr>
+          <p:cNvPr id="176" name="S176"/>
+          <p:cNvSpPr/>
+          <p:nvPr/>
+        </p:nvSpPr>
+        <p:spPr>
+          <a:xfrm>
+            <a:off x="6553200" y="5537200"/>
+            <a:ext cx="5461000" cy="279400"/>
+          </a:xfrm>
+          <a:prstGeom prst="roundRect">
+            <a:avLst>
+              <a:gd name="adj" fmla="val 10000"/>
+            </a:avLst>
+          </a:prstGeom>
+          <a:solidFill>
+            <a:srgbClr val="F5F3FF"/>
+          </a:solidFill>
+          <a:ln w="6350">
             <a:solidFill>
               <a:srgbClr val="7C3AED"/>
             </a:solidFill>
           </a:ln>
         </p:spPr>
-      </p:cxnSp>
-      <p:sp>
-        <p:nvSpPr>
-          <p:cNvPr id="138" name="T138"/>
-          <p:cNvSpPr/>
-          <p:nvPr/>
-        </p:nvSpPr>
-        <p:spPr>
-          <a:xfrm>
-            <a:off x="10109200" y="2133600"/>
-            <a:ext cx="1727200" cy="1244600"/>
-          </a:xfrm>
-          <a:prstGeom prst="rect">
-            <a:avLst/>
-          </a:prstGeom>
-          <a:noFill/>
-          <a:ln w="0">
-            <a:noFill/>
-          </a:ln>
-        </p:spPr>
-        <p:txBody>
-          <a:bodyPr wrap="square" lIns="0" tIns="0" rIns="0" bIns="0" anchor="t"/>
-          <a:lstStyle/>
-          <a:p>
-            <a:pPr algn="ctr">
-              <a:buNone/>
-            </a:pPr>
-            <a:r>
-              <a:rPr lang="en-US" sz="1200" dirty="0">
-                <a:solidFill>
-                  <a:srgbClr val="475569"/>
+        <p:txBody>
+          <a:bodyPr wrap="square" lIns="36000" tIns="18000" rIns="36000" bIns="18000" anchor="ctr"/>
+          <a:lstStyle/>
+          <a:p>
+            <a:pPr algn="l">
+              <a:buNone/>
+            </a:pPr>
+            <a:r>
+              <a:rPr lang="en-US" sz="900" dirty="0">
+                <a:solidFill>
+                  <a:srgbClr val="7C3AED"/>
                 </a:solidFill>
                 <a:latin typeface="Aptos"/>
               </a:rPr>
-              <a:t>Strongest reasoning for complex architecture, long-running agentic work, and cross-cutting decisions. Pro/Max/Team/Enterprise.</a:t>
-            </a:r>
-          </a:p>
-        </p:txBody>
-      </p:sp>
-      <p:sp>
-        <p:nvSpPr>
-          <p:cNvPr id="139" name="S139"/>
-          <p:cNvSpPr/>
-          <p:nvPr/>
-        </p:nvSpPr>
-        <p:spPr>
-          <a:xfrm>
-            <a:off x="381000" y="5994420"/>
-            <a:ext cx="11430000" cy="253980"/>
+              <a:t>Architect  =  Opus 4.6  (Complex design &amp; architecture)</a:t>
+            </a:r>
+          </a:p>
+        </p:txBody>
+      </p:sp>
+      <p:sp>
+        <p:nvSpPr>
+          <p:cNvPr id="177" name="S177"/>
+          <p:cNvSpPr/>
+          <p:nvPr/>
+        </p:nvSpPr>
+        <p:spPr>
+          <a:xfrm>
+            <a:off x="6553200" y="5867400"/>
+            <a:ext cx="5461000" cy="279400"/>
           </a:xfrm>
           <a:prstGeom prst="roundRect">
             <a:avLst>
-              <a:gd name="adj" fmla="val 6000"/>
+              <a:gd name="adj" fmla="val 10000"/>
+            </a:avLst>
+          </a:prstGeom>
+          <a:solidFill>
+            <a:srgbClr val="F0F9FF"/>
+          </a:solidFill>
+          <a:ln w="6350">
+            <a:solidFill>
+              <a:srgbClr val="0EA5E9"/>
+            </a:solidFill>
+          </a:ln>
+        </p:spPr>
+        <p:txBody>
+          <a:bodyPr wrap="square" lIns="36000" tIns="18000" rIns="36000" bIns="18000" anchor="ctr"/>
+          <a:lstStyle/>
+          <a:p>
+            <a:pPr algn="l">
+              <a:buNone/>
+            </a:pPr>
+            <a:r>
+              <a:rPr lang="en-US" sz="900" dirty="0">
+                <a:solidFill>
+                  <a:srgbClr val="0EA5E9"/>
+                </a:solidFill>
+                <a:latin typeface="Aptos"/>
+              </a:rPr>
+              <a:t>Engineers  =  Haiku 4.5  (Fast subtasks, parallel work)</a:t>
+            </a:r>
+          </a:p>
+        </p:txBody>
+      </p:sp>
+      <p:sp>
+        <p:nvSpPr>
+          <p:cNvPr id="178" name="S178"/>
+          <p:cNvSpPr/>
+          <p:nvPr/>
+        </p:nvSpPr>
+        <p:spPr>
+          <a:xfrm>
+            <a:off x="177800" y="6289040"/>
+            <a:ext cx="11836398" cy="254000"/>
+          </a:xfrm>
+          <a:prstGeom prst="roundRect">
+            <a:avLst>
+              <a:gd name="adj" fmla="val 16667"/>
             </a:avLst>
           </a:prstGeom>
           <a:solidFill>
             <a:srgbClr val="EFF6FF"/>
           </a:solidFill>
-          <a:ln w="0">
-            <a:noFill/>
-          </a:ln>
-          <a:effectLst>
-            <a:outerShdw blurRad="25400" dist="12700" dir="5400000" algn="tl" rotWithShape="0">
-              <a:srgbClr val="000000">
-                <a:alpha val="10000"/>
-              </a:srgbClr>
-            </a:outerShdw>
-          </a:effectLst>
-        </p:spPr>
-        <p:txBody>
-          <a:bodyPr wrap="square" lIns="72000" tIns="54000" rIns="72000" bIns="54000" anchor="t"/>
+          <a:ln w="6350">
+            <a:solidFill>
+              <a:srgbClr val="93C5FD"/>
+            </a:solidFill>
+          </a:ln>
+        </p:spPr>
+        <p:txBody>
+          <a:bodyPr wrap="square" lIns="36000" tIns="18000" rIns="36000" bIns="18000" anchor="ctr"/>
           <a:lstStyle/>
           <a:p>
             <a:pPr algn="ctr">
               <a:buNone/>
             </a:pPr>
             <a:r>
-              <a:rPr lang="en-US" sz="1100" b="1" dirty="0">
+              <a:rPr lang="en-US" sz="1050" b="1" dirty="0">
                 <a:solidFill>
                   <a:srgbClr val="1E40AF"/>
                 </a:solidFill>
@@ -22390,21 +23759,133 @@
               <a:t>Operating rule:  </a:t>
             </a:r>
             <a:r>
-              <a:rPr lang="en-US" sz="1100" dirty="0">
+              <a:rPr lang="en-US" sz="1050" dirty="0">
                 <a:solidFill>
                   <a:srgbClr val="1E40AF"/>
                 </a:solidFill>
                 <a:latin typeface="Aptos"/>
               </a:rPr>
-              <a:t>Use Sonnet 4.6 by default. Escalate to Opus 4.6 for ambiguity, architecture, or long-horizon work. Use Haiku 4.5 for speed, triage, and parallel subtasks.</a:t>
-            </a:r>
-          </a:p>
-        </p:txBody>
-      </p:sp>
+              <a:t>Sonnet by default → Opus for architecture → Haiku for speed &amp; parallel subtasks.</a:t>
+            </a:r>
+          </a:p>
+        </p:txBody>
+      </p:sp>
+      <p:grpSp>
+        <p:nvGrpSpPr>
+          <p:cNvPr id="3" name="Group 2">
+            <a:extLst>
+              <a:ext uri="{FF2B5EF4-FFF2-40B4-BE49-F238E27FC236}">
+                <a16:creationId xmlns:a16="http://schemas.microsoft.com/office/drawing/2014/main" id="{0FCFBD22-D1A3-61AE-D3E2-A824D70F16CD}"/>
+              </a:ext>
+            </a:extLst>
+          </p:cNvPr>
+          <p:cNvGrpSpPr/>
+          <p:nvPr/>
+        </p:nvGrpSpPr>
+        <p:grpSpPr>
+          <a:xfrm>
+            <a:off x="6223000" y="965200"/>
+            <a:ext cx="152400" cy="5232400"/>
+            <a:chOff x="6223000" y="965200"/>
+            <a:chExt cx="152400" cy="5232400"/>
+          </a:xfrm>
+        </p:grpSpPr>
+        <p:cxnSp>
+          <p:nvCxnSpPr>
+            <p:cNvPr id="139" name="L139"/>
+            <p:cNvCxnSpPr/>
+            <p:nvPr/>
+          </p:nvCxnSpPr>
+          <p:spPr>
+            <a:xfrm>
+              <a:off x="6299200" y="990600"/>
+              <a:ext cx="0" cy="5105400"/>
+            </a:xfrm>
+            <a:prstGeom prst="line">
+              <a:avLst/>
+            </a:prstGeom>
+            <a:ln w="25400">
+              <a:solidFill>
+                <a:srgbClr val="CBD5E1"/>
+              </a:solidFill>
+            </a:ln>
+          </p:spPr>
+        </p:cxnSp>
+        <p:sp>
+          <p:nvSpPr>
+            <p:cNvPr id="140" name="S140"/>
+            <p:cNvSpPr/>
+            <p:nvPr/>
+          </p:nvSpPr>
+          <p:spPr>
+            <a:xfrm>
+              <a:off x="6223000" y="965200"/>
+              <a:ext cx="152400" cy="152400"/>
+            </a:xfrm>
+            <a:prstGeom prst="ellipse">
+              <a:avLst/>
+            </a:prstGeom>
+            <a:solidFill>
+              <a:srgbClr val="CBD5E1"/>
+            </a:solidFill>
+            <a:ln>
+              <a:noFill/>
+            </a:ln>
+          </p:spPr>
+          <p:txBody>
+            <a:bodyPr wrap="square" lIns="36000" tIns="18000" rIns="36000" bIns="18000" anchor="ctr"/>
+            <a:lstStyle/>
+            <a:p>
+              <a:pPr algn="ctr">
+                <a:buNone/>
+              </a:pPr>
+              <a:endParaRPr/>
+            </a:p>
+          </p:txBody>
+        </p:sp>
+        <p:sp>
+          <p:nvSpPr>
+            <p:cNvPr id="2" name="S140">
+              <a:extLst>
+                <a:ext uri="{FF2B5EF4-FFF2-40B4-BE49-F238E27FC236}">
+                  <a16:creationId xmlns:a16="http://schemas.microsoft.com/office/drawing/2014/main" id="{4EE407DE-B74F-9FDA-20B8-130E86A0DB0F}"/>
+                </a:ext>
+              </a:extLst>
+            </p:cNvPr>
+            <p:cNvSpPr/>
+            <p:nvPr/>
+          </p:nvSpPr>
+          <p:spPr>
+            <a:xfrm>
+              <a:off x="6223000" y="6045200"/>
+              <a:ext cx="152400" cy="152400"/>
+            </a:xfrm>
+            <a:prstGeom prst="ellipse">
+              <a:avLst/>
+            </a:prstGeom>
+            <a:solidFill>
+              <a:srgbClr val="CBD5E1"/>
+            </a:solidFill>
+            <a:ln>
+              <a:noFill/>
+            </a:ln>
+          </p:spPr>
+          <p:txBody>
+            <a:bodyPr wrap="square" lIns="36000" tIns="18000" rIns="36000" bIns="18000" anchor="ctr"/>
+            <a:lstStyle/>
+            <a:p>
+              <a:pPr algn="ctr">
+                <a:buNone/>
+              </a:pPr>
+              <a:endParaRPr/>
+            </a:p>
+          </p:txBody>
+        </p:sp>
+      </p:grpSp>
     </p:spTree>
     <p:extLst>
       <p:ext uri="{BB962C8B-B14F-4D97-AF65-F5344CB8AC3E}">
-        <p14:creationId xmlns:p14="http://schemas.microsoft.com/office/powerpoint/2010/main" val="3352176317"/>
+        <p14:creationId xmlns:p14="http://schemas.microsoft.com/office/powerpoint/2010/main" val="3978852896"/>
       </p:ext>
     </p:extLst>
   </p:cSld>

</xml_diff>

<commit_message>
Updated the admin dashboard with metrics
</commit_message>
<xml_diff>
--- a/Claude_Code_Agentic_Engineering_Session.pptx
+++ b/Claude_Code_Agentic_Engineering_Session.pptx
@@ -1395,7 +1395,7 @@
           <a:p>
             <a:fld id="{FE9AFDDE-3A13-46FC-B67A-2ECE1914331B}" type="datetimeFigureOut">
               <a:rPr lang="en-US" smtClean="0"/>
-              <a:t>3/19/26</a:t>
+              <a:t>3/20/26</a:t>
             </a:fld>
             <a:endParaRPr lang="en-US"/>
           </a:p>
@@ -27745,9 +27745,9 @@
         <p:grpSpPr>
           <a:xfrm>
             <a:off x="510764" y="1024201"/>
-            <a:ext cx="10831496" cy="5363565"/>
+            <a:ext cx="10831496" cy="5385995"/>
             <a:chOff x="523141" y="968227"/>
-            <a:chExt cx="10831496" cy="5531548"/>
+            <a:chExt cx="10831496" cy="5554681"/>
           </a:xfrm>
         </p:grpSpPr>
         <p:grpSp>
@@ -27765,9 +27765,9 @@
           <p:grpSpPr>
             <a:xfrm>
               <a:off x="523141" y="968227"/>
-              <a:ext cx="10831496" cy="5531548"/>
+              <a:ext cx="10831496" cy="5554681"/>
               <a:chOff x="300623" y="980102"/>
-              <a:chExt cx="10831496" cy="5531548"/>
+              <a:chExt cx="10831496" cy="5554681"/>
             </a:xfrm>
           </p:grpSpPr>
           <p:grpSp>
@@ -28284,9 +28284,9 @@
               </p:nvGrpSpPr>
               <p:grpSpPr>
                 <a:xfrm>
-                  <a:off x="2181684" y="2653717"/>
+                  <a:off x="2255044" y="2653717"/>
                   <a:ext cx="1637239" cy="2612167"/>
-                  <a:chOff x="-192268" y="2660073"/>
+                  <a:chOff x="-118509" y="2660073"/>
                   <a:chExt cx="1646109" cy="2626318"/>
                 </a:xfrm>
               </p:grpSpPr>
@@ -28304,9 +28304,9 @@
                 </p:nvGrpSpPr>
                 <p:grpSpPr>
                   <a:xfrm>
-                    <a:off x="-192268" y="2660073"/>
+                    <a:off x="-118509" y="2660073"/>
                     <a:ext cx="1646109" cy="2626318"/>
-                    <a:chOff x="-277415" y="3032271"/>
+                    <a:chOff x="-173892" y="3032271"/>
                     <a:chExt cx="2310297" cy="2846889"/>
                   </a:xfrm>
                 </p:grpSpPr>
@@ -28324,8 +28324,8 @@
                   </p:nvSpPr>
                   <p:spPr>
                     <a:xfrm>
-                      <a:off x="48427" y="3429000"/>
-                      <a:ext cx="1658621" cy="2054431"/>
+                      <a:off x="151950" y="3429000"/>
+                      <a:ext cx="1658620" cy="2054431"/>
                     </a:xfrm>
                     <a:prstGeom prst="rect">
                       <a:avLst/>
@@ -28378,8 +28378,8 @@
                   </p:nvSpPr>
                   <p:spPr>
                     <a:xfrm rot="10800000">
-                      <a:off x="-277408" y="3032271"/>
-                      <a:ext cx="2310290" cy="404536"/>
+                      <a:off x="-173885" y="3032271"/>
+                      <a:ext cx="2310290" cy="404535"/>
                     </a:xfrm>
                     <a:prstGeom prst="trapezoid">
                       <a:avLst>
@@ -28434,8 +28434,8 @@
                   </p:nvSpPr>
                   <p:spPr>
                     <a:xfrm rot="10800000" flipV="1">
-                      <a:off x="-277415" y="5474624"/>
-                      <a:ext cx="2310293" cy="404536"/>
+                      <a:off x="-173892" y="5474625"/>
+                      <a:ext cx="2310293" cy="404535"/>
                     </a:xfrm>
                     <a:prstGeom prst="trapezoid">
                       <a:avLst>
@@ -28491,7 +28491,7 @@
                 </p:nvSpPr>
                 <p:spPr>
                   <a:xfrm>
-                    <a:off x="188392" y="3531967"/>
+                    <a:off x="262152" y="3531967"/>
                     <a:ext cx="914400" cy="914400"/>
                   </a:xfrm>
                   <a:prstGeom prst="ellipse">
@@ -28544,9 +28544,9 @@
               </p:nvGrpSpPr>
               <p:grpSpPr>
                 <a:xfrm>
-                  <a:off x="3991397" y="2673999"/>
+                  <a:off x="4085717" y="2673999"/>
                   <a:ext cx="1637248" cy="2612167"/>
-                  <a:chOff x="-413552" y="2660073"/>
+                  <a:chOff x="-318719" y="2660073"/>
                   <a:chExt cx="1646117" cy="2626318"/>
                 </a:xfrm>
               </p:grpSpPr>
@@ -28564,9 +28564,9 @@
                 </p:nvGrpSpPr>
                 <p:grpSpPr>
                   <a:xfrm>
-                    <a:off x="-413552" y="2660073"/>
+                    <a:off x="-318719" y="2660073"/>
                     <a:ext cx="1646117" cy="2626318"/>
-                    <a:chOff x="-587987" y="3032271"/>
+                    <a:chOff x="-454886" y="3032271"/>
                     <a:chExt cx="2310304" cy="2846889"/>
                   </a:xfrm>
                 </p:grpSpPr>
@@ -28584,7 +28584,7 @@
                   </p:nvSpPr>
                   <p:spPr>
                     <a:xfrm>
-                      <a:off x="-262155" y="3429000"/>
+                      <a:off x="-129054" y="3429000"/>
                       <a:ext cx="1658620" cy="2054431"/>
                     </a:xfrm>
                     <a:prstGeom prst="rect">
@@ -28638,8 +28638,8 @@
                   </p:nvSpPr>
                   <p:spPr>
                     <a:xfrm rot="10800000">
-                      <a:off x="-587974" y="3032271"/>
-                      <a:ext cx="2310291" cy="404536"/>
+                      <a:off x="-454873" y="3032271"/>
+                      <a:ext cx="2310291" cy="404535"/>
                     </a:xfrm>
                     <a:prstGeom prst="trapezoid">
                       <a:avLst>
@@ -28694,8 +28694,8 @@
                   </p:nvSpPr>
                   <p:spPr>
                     <a:xfrm rot="10800000" flipV="1">
-                      <a:off x="-587987" y="5474624"/>
-                      <a:ext cx="2310291" cy="404536"/>
+                      <a:off x="-454886" y="5474625"/>
+                      <a:ext cx="2310291" cy="404535"/>
                     </a:xfrm>
                     <a:prstGeom prst="trapezoid">
                       <a:avLst>
@@ -28751,8 +28751,8 @@
                 </p:nvSpPr>
                 <p:spPr>
                   <a:xfrm>
-                    <a:off x="-47709" y="3521969"/>
-                    <a:ext cx="914400" cy="914400"/>
+                    <a:off x="47125" y="3521969"/>
+                    <a:ext cx="914401" cy="914400"/>
                   </a:xfrm>
                   <a:prstGeom prst="ellipse">
                     <a:avLst/>
@@ -28804,9 +28804,9 @@
               </p:nvGrpSpPr>
               <p:grpSpPr>
                 <a:xfrm>
-                  <a:off x="5884942" y="2653717"/>
+                  <a:off x="5958302" y="2653717"/>
                   <a:ext cx="1637239" cy="2612167"/>
-                  <a:chOff x="-550549" y="2660073"/>
+                  <a:chOff x="-476790" y="2660073"/>
                   <a:chExt cx="1646109" cy="2626318"/>
                 </a:xfrm>
               </p:grpSpPr>
@@ -28824,9 +28824,9 @@
                 </p:nvGrpSpPr>
                 <p:grpSpPr>
                   <a:xfrm>
-                    <a:off x="-550549" y="2660073"/>
+                    <a:off x="-476790" y="2660073"/>
                     <a:ext cx="1646109" cy="2626318"/>
-                    <a:chOff x="-780246" y="3032271"/>
+                    <a:chOff x="-676723" y="3032271"/>
                     <a:chExt cx="2310295" cy="2846889"/>
                   </a:xfrm>
                 </p:grpSpPr>
@@ -28844,8 +28844,8 @@
                   </p:nvSpPr>
                   <p:spPr>
                     <a:xfrm>
-                      <a:off x="-454412" y="3429000"/>
-                      <a:ext cx="1658623" cy="2054431"/>
+                      <a:off x="-350884" y="3429000"/>
+                      <a:ext cx="1658624" cy="2054431"/>
                     </a:xfrm>
                     <a:prstGeom prst="rect">
                       <a:avLst/>
@@ -28898,8 +28898,8 @@
                   </p:nvSpPr>
                   <p:spPr>
                     <a:xfrm rot="10800000">
-                      <a:off x="-780243" y="3032271"/>
-                      <a:ext cx="2310292" cy="404536"/>
+                      <a:off x="-676720" y="3032271"/>
+                      <a:ext cx="2310292" cy="404535"/>
                     </a:xfrm>
                     <a:prstGeom prst="trapezoid">
                       <a:avLst>
@@ -28954,8 +28954,8 @@
                   </p:nvSpPr>
                   <p:spPr>
                     <a:xfrm rot="10800000" flipV="1">
-                      <a:off x="-780246" y="5474624"/>
-                      <a:ext cx="2310289" cy="404536"/>
+                      <a:off x="-676723" y="5474625"/>
+                      <a:ext cx="2310289" cy="404535"/>
                     </a:xfrm>
                     <a:prstGeom prst="trapezoid">
                       <a:avLst>
@@ -29011,7 +29011,7 @@
                 </p:nvSpPr>
                 <p:spPr>
                   <a:xfrm>
-                    <a:off x="-184697" y="3521969"/>
+                    <a:off x="-110938" y="3521969"/>
                     <a:ext cx="914400" cy="914400"/>
                   </a:xfrm>
                   <a:prstGeom prst="ellipse">
@@ -29064,9 +29064,9 @@
               </p:nvGrpSpPr>
               <p:grpSpPr>
                 <a:xfrm>
-                  <a:off x="7768021" y="2653717"/>
+                  <a:off x="7862341" y="2653717"/>
                   <a:ext cx="1637241" cy="2612167"/>
-                  <a:chOff x="-698069" y="2660073"/>
+                  <a:chOff x="-603236" y="2660073"/>
                   <a:chExt cx="1646111" cy="2626318"/>
                 </a:xfrm>
               </p:grpSpPr>
@@ -29084,9 +29084,9 @@
                 </p:nvGrpSpPr>
                 <p:grpSpPr>
                   <a:xfrm>
-                    <a:off x="-698069" y="2660073"/>
+                    <a:off x="-603236" y="2660073"/>
                     <a:ext cx="1646111" cy="2626318"/>
-                    <a:chOff x="-987294" y="3032271"/>
+                    <a:chOff x="-854193" y="3032271"/>
                     <a:chExt cx="2310297" cy="2846889"/>
                   </a:xfrm>
                 </p:grpSpPr>
@@ -29104,7 +29104,7 @@
                   </p:nvSpPr>
                   <p:spPr>
                     <a:xfrm>
-                      <a:off x="-661452" y="3429000"/>
+                      <a:off x="-528352" y="3429000"/>
                       <a:ext cx="1658620" cy="2054431"/>
                     </a:xfrm>
                     <a:prstGeom prst="rect">
@@ -29158,8 +29158,8 @@
                   </p:nvSpPr>
                   <p:spPr>
                     <a:xfrm rot="10800000">
-                      <a:off x="-987287" y="3032271"/>
-                      <a:ext cx="2310290" cy="404536"/>
+                      <a:off x="-854186" y="3032271"/>
+                      <a:ext cx="2310290" cy="404535"/>
                     </a:xfrm>
                     <a:prstGeom prst="trapezoid">
                       <a:avLst>
@@ -29214,8 +29214,8 @@
                   </p:nvSpPr>
                   <p:spPr>
                     <a:xfrm rot="10800000" flipV="1">
-                      <a:off x="-987294" y="5474624"/>
-                      <a:ext cx="2310293" cy="404536"/>
+                      <a:off x="-854193" y="5474625"/>
+                      <a:ext cx="2310293" cy="404535"/>
                     </a:xfrm>
                     <a:prstGeom prst="trapezoid">
                       <a:avLst>
@@ -29271,7 +29271,7 @@
                 </p:nvSpPr>
                 <p:spPr>
                   <a:xfrm>
-                    <a:off x="-330955" y="3531967"/>
+                    <a:off x="-236122" y="3531967"/>
                     <a:ext cx="914400" cy="914400"/>
                   </a:xfrm>
                   <a:prstGeom prst="ellipse">
@@ -29550,7 +29550,7 @@
             <p:spPr>
               <a:xfrm>
                 <a:off x="7476516" y="5772985"/>
-                <a:ext cx="1569686" cy="738664"/>
+                <a:ext cx="1569686" cy="761798"/>
               </a:xfrm>
               <a:prstGeom prst="rect">
                 <a:avLst/>
@@ -29586,7 +29586,7 @@
                     </a:solidFill>
                     <a:latin typeface="Aptos"/>
                   </a:rPr>
-                  <a:t>SSO, SCIM, spend controls, Compliance API.</a:t>
+                  <a:t>Prevent hallucinations by grounding in files, evidence, and tests.</a:t>
                 </a:r>
               </a:p>
             </p:txBody>
@@ -29650,9 +29650,9 @@
           <p:grpSpPr>
             <a:xfrm>
               <a:off x="1286472" y="2688301"/>
-              <a:ext cx="9957633" cy="3626808"/>
+              <a:ext cx="9957633" cy="3644159"/>
               <a:chOff x="1286472" y="2688301"/>
-              <a:chExt cx="9957633" cy="3626808"/>
+              <a:chExt cx="9957633" cy="3644159"/>
             </a:xfrm>
           </p:grpSpPr>
           <p:sp>
@@ -29669,7 +29669,7 @@
             </p:nvSpPr>
             <p:spPr>
               <a:xfrm>
-                <a:off x="9705709" y="3037301"/>
+                <a:off x="9786094" y="3037301"/>
                 <a:ext cx="1126918" cy="1807270"/>
               </a:xfrm>
               <a:prstGeom prst="rect">
@@ -29726,7 +29726,7 @@
             </p:nvSpPr>
             <p:spPr>
               <a:xfrm rot="10800000">
-                <a:off x="9484327" y="2688301"/>
+                <a:off x="9564712" y="2688301"/>
                 <a:ext cx="1569684" cy="355868"/>
               </a:xfrm>
               <a:prstGeom prst="trapezoid">
@@ -29785,7 +29785,7 @@
             </p:nvSpPr>
             <p:spPr>
               <a:xfrm rot="10800000" flipV="1">
-                <a:off x="9484322" y="4836823"/>
+                <a:off x="9564707" y="4836823"/>
                 <a:ext cx="1569686" cy="355868"/>
               </a:xfrm>
               <a:prstGeom prst="trapezoid">
@@ -29844,7 +29844,7 @@
             </p:nvSpPr>
             <p:spPr>
               <a:xfrm>
-                <a:off x="9884631" y="3519717"/>
+                <a:off x="9965016" y="3519717"/>
                 <a:ext cx="871948" cy="871949"/>
               </a:xfrm>
               <a:prstGeom prst="ellipse">
@@ -29897,7 +29897,7 @@
             <p:spPr>
               <a:xfrm>
                 <a:off x="9369009" y="5761111"/>
-                <a:ext cx="1875096" cy="553998"/>
+                <a:ext cx="1875096" cy="571349"/>
               </a:xfrm>
               <a:prstGeom prst="rect">
                 <a:avLst/>
@@ -29933,7 +29933,7 @@
                     </a:solidFill>
                     <a:latin typeface="Aptos"/>
                   </a:rPr>
-                  <a:t>SSO, SCIM, spend controls, Compliance API.</a:t>
+                  <a:t>SSO, SCIM, Spend Controls, Compliance API.</a:t>
                 </a:r>
               </a:p>
             </p:txBody>
@@ -30002,7 +30002,7 @@
             </p:blipFill>
             <p:spPr>
               <a:xfrm>
-                <a:off x="2939152" y="3688585"/>
+                <a:off x="3009488" y="3688585"/>
                 <a:ext cx="412984" cy="412984"/>
               </a:xfrm>
               <a:prstGeom prst="rect">
@@ -30038,7 +30038,7 @@
             </p:blipFill>
             <p:spPr>
               <a:xfrm>
-                <a:off x="4662160" y="3738823"/>
+                <a:off x="4752592" y="3738823"/>
                 <a:ext cx="412258" cy="412258"/>
               </a:xfrm>
               <a:prstGeom prst="rect">
@@ -30074,7 +30074,7 @@
             </p:blipFill>
             <p:spPr>
               <a:xfrm>
-                <a:off x="6440992" y="3684107"/>
+                <a:off x="6511328" y="3684107"/>
                 <a:ext cx="480648" cy="480648"/>
               </a:xfrm>
               <a:prstGeom prst="rect">
@@ -30110,7 +30110,7 @@
             </p:blipFill>
             <p:spPr>
               <a:xfrm>
-                <a:off x="8268960" y="3698630"/>
+                <a:off x="8359392" y="3698630"/>
                 <a:ext cx="442961" cy="442961"/>
               </a:xfrm>
               <a:prstGeom prst="rect">
@@ -30146,7 +30146,7 @@
             </p:blipFill>
             <p:spPr>
               <a:xfrm>
-                <a:off x="10082408" y="3708680"/>
+                <a:off x="10162793" y="3708680"/>
                 <a:ext cx="458313" cy="458313"/>
               </a:xfrm>
               <a:prstGeom prst="rect">

</xml_diff>